<commit_message>
Restyle APMT coaching deck to the L&D Field Team Synthesia template
Co-Authored-By: Claude Opus 5.5 <noreply@anthropic.com>
Claude-Session: https://claude.ai/code/session_01Cr6d8mb1XkHfhN1yyjHEjG
</commit_message>
<xml_diff>
--- a/APMT_Coaching_FFF_ROBOTSS.pptx
+++ b/APMT_Coaching_FFF_ROBOTSS.pptx
@@ -121,14 +121,14 @@
   <p:extLst>
     <p:ext uri="{521415D9-36F7-43E2-AB2F-B90AF26B5E84}">
       <p14:sectionLst xmlns:p14="http://schemas.microsoft.com/office/powerpoint/2010/main">
-        <p14:section name="Intro" id="{becc3986-ee48-c7b4-05f2-e364b9f5f11b}">
+        <p14:section name="Intro" id="{3b41efca-03fa-eae0-0946-bfdaa6dfaae8}">
           <p14:sldIdLst>
             <p14:sldId id="256"/>
             <p14:sldId id="257"/>
             <p14:sldId id="258"/>
           </p14:sldIdLst>
         </p14:section>
-        <p14:section name="First Face Fix" id="{768e0436-3a7b-30d3-8648-da5c865410ab}">
+        <p14:section name="First Face Fix" id="{631087e7-78ba-cbfe-56b8-2023815c5670}">
           <p14:sldIdLst>
             <p14:sldId id="259"/>
             <p14:sldId id="260"/>
@@ -137,7 +137,7 @@
             <p14:sldId id="263"/>
           </p14:sldIdLst>
         </p14:section>
-        <p14:section name="ROBOTSS" id="{1d055b9e-87a7-f618-a1b3-dedd57c7702a}">
+        <p14:section name="ROBOTSS" id="{26385f28-e183-e6db-a865-5085531b691a}">
           <p14:sldIdLst>
             <p14:sldId id="264"/>
             <p14:sldId id="265"/>
@@ -146,7 +146,7 @@
             <p14:sldId id="268"/>
           </p14:sldIdLst>
         </p14:section>
-        <p14:section name="Wrap-up" id="{77119a3e-ffd8-c540-c73d-c6f0f6800e08}">
+        <p14:section name="Wrap-up" id="{3aa10d09-f237-2a6f-18be-0c14784b818d}">
           <p14:sldIdLst>
             <p14:sldId id="269"/>
             <p14:sldId id="270"/>
@@ -1084,7 +1084,7 @@
           <a:p>
             <a:r>
               <a:rPr lang="en-US" dirty="0"/>
-              <a:t>Small fixes make a big impact. Thanks for watching, and thanks for looking after every bin, every time. If you have any questions, speak to your Process Guide, your Area Manager, or the ICQA team.</a:t>
+              <a:t>Small fixes make a big impact. Thanks for watching, and thanks for looking after every bin, every time. If you have any questions, speak to your Process Guide, your Area Manager, or the ICQA team. And please take a second to rate this video.</a:t>
             </a:r>
             <a:endParaRPr lang="en-US" dirty="0"/>
           </a:p>
@@ -1862,11 +1862,11 @@
 
 <file path=ppt/slideLayouts/slideLayout2.xml><?xml version="1.0" encoding="utf-8"?>
 <p:sldLayout xmlns:a="http://schemas.openxmlformats.org/drawingml/2006/main" xmlns:r="http://schemas.openxmlformats.org/officeDocument/2006/relationships" xmlns:p="http://schemas.openxmlformats.org/presentationml/2006/main" preserve="1">
-  <p:cSld name="DARK_TITLE">
+  <p:cSld name="TITLE_SCENE">
     <p:bg>
       <p:bgPr>
         <a:solidFill>
-          <a:schemeClr val="tx2"/>
+          <a:schemeClr val="bg2"/>
         </a:solidFill>
       </p:bgPr>
     </p:bg>
@@ -1886,85 +1886,51 @@
       </p:grpSpPr>
       <p:sp>
         <p:nvSpPr>
-          <p:cNvPr id="2" name="Text 0"/>
+          <p:cNvPr id="2" name="Shape 0"/>
           <p:cNvSpPr/>
-          <p:nvPr>
-            <p:ph idx="100" type="body" hasCustomPrompt="1"/>
-          </p:nvPr>
-        </p:nvSpPr>
-        <p:spPr>
-          <a:xfrm>
-            <a:off x="457200" y="1143000"/>
-            <a:ext cx="5394960" cy="365760"/>
-          </a:xfrm>
-          <a:prstGeom prst="rect">
-            <a:avLst/>
-          </a:prstGeom>
-          <a:noFill/>
-          <a:ln/>
-        </p:spPr>
-        <p:txBody>
-          <a:bodyPr wrap="square" rtlCol="0"/>
-          <a:lstStyle>
-            <a:lvl1pPr indent="0" marL="0">
-              <a:buNone/>
-              <a:defRPr lang="en-US" sz="1400" b="1" spc="300" kern="0" dirty="0">
-                <a:solidFill>
-                  <a:schemeClr val="accent1"/>
-                </a:solidFill>
-              </a:defRPr>
-            </a:lvl1pPr>
-          </a:lstStyle>
-          <a:p>
-            <a:pPr indent="0" marL="0">
-              <a:buNone/>
-            </a:pPr>
-            <a:endParaRPr lang="en-US" sz="1400" dirty="0"/>
-          </a:p>
-        </p:txBody>
-      </p:sp>
-      <p:sp>
-        <p:nvSpPr>
-          <p:cNvPr id="3" name="Text 0"/>
-          <p:cNvSpPr/>
-          <p:nvPr>
-            <p:ph idx="101" type="title" hasCustomPrompt="1"/>
-          </p:nvPr>
-        </p:nvSpPr>
-        <p:spPr>
-          <a:xfrm>
-            <a:off x="457200" y="1554480"/>
-            <a:ext cx="5394960" cy="1463040"/>
-          </a:xfrm>
-          <a:prstGeom prst="rect">
-            <a:avLst/>
-          </a:prstGeom>
-          <a:noFill/>
-          <a:ln/>
-        </p:spPr>
-        <p:txBody>
-          <a:bodyPr wrap="square" rtlCol="0"/>
-          <a:lstStyle>
-            <a:lvl1pPr algn="l" indent="0" marL="0">
-              <a:buNone/>
-              <a:defRPr lang="en-US" sz="4000" b="1" dirty="0">
-                <a:solidFill>
-                  <a:schemeClr val="bg1"/>
-                </a:solidFill>
-              </a:defRPr>
-            </a:lvl1pPr>
-          </a:lstStyle>
-          <a:p>
-            <a:pPr algn="l" indent="0" marL="0">
-              <a:buNone/>
-            </a:pPr>
-            <a:endParaRPr lang="en-US" sz="4000" dirty="0"/>
-          </a:p>
-        </p:txBody>
-      </p:sp>
-      <p:sp>
-        <p:nvSpPr>
-          <p:cNvPr id="4" name="Text 0"/>
+          <p:nvPr/>
+        </p:nvSpPr>
+        <p:spPr>
+          <a:xfrm>
+            <a:off x="0" y="0"/>
+            <a:ext cx="2286000" cy="5143500"/>
+          </a:xfrm>
+          <a:prstGeom prst="rect">
+            <a:avLst/>
+          </a:prstGeom>
+          <a:solidFill>
+            <a:schemeClr val="tx2"/>
+          </a:solidFill>
+          <a:ln/>
+        </p:spPr>
+      </p:sp>
+      <p:pic>
+        <p:nvPicPr>
+          <p:cNvPr id="3" name="Image 0" descr="preencoded.png">    </p:cNvPr>
+          <p:cNvPicPr>
+            <a:picLocks noChangeAspect="1"/>
+          </p:cNvPicPr>
+          <p:nvPr/>
+        </p:nvPicPr>
+        <p:blipFill>
+          <a:blip r:embed="rId1"/>
+          <a:stretch>
+            <a:fillRect/>
+          </a:stretch>
+        </p:blipFill>
+        <p:spPr>
+          <a:xfrm>
+            <a:off x="5166360" y="2606040"/>
+            <a:ext cx="1097280" cy="1225296"/>
+          </a:xfrm>
+          <a:prstGeom prst="rect">
+            <a:avLst/>
+          </a:prstGeom>
+        </p:spPr>
+      </p:pic>
+      <p:sp>
+        <p:nvSpPr>
+          <p:cNvPr id="4" name="Text 1"/>
           <p:cNvSpPr/>
           <p:nvPr>
             <p:ph idx="102" type="body" hasCustomPrompt="1"/>
@@ -1972,8 +1938,8 @@
         </p:nvSpPr>
         <p:spPr>
           <a:xfrm>
-            <a:off x="457200" y="3063240"/>
-            <a:ext cx="4846320" cy="822960"/>
+            <a:off x="2514600" y="502920"/>
+            <a:ext cx="6400800" cy="320040"/>
           </a:xfrm>
           <a:prstGeom prst="rect">
             <a:avLst/>
@@ -1984,20 +1950,98 @@
         <p:txBody>
           <a:bodyPr wrap="square" rtlCol="0"/>
           <a:lstStyle>
-            <a:lvl1pPr indent="0" marL="0">
-              <a:buNone/>
-              <a:defRPr lang="en-US" sz="1800" dirty="0">
-                <a:solidFill>
-                  <a:srgbClr val="C9D3DD"/>
+            <a:lvl1pPr algn="ctr" indent="0" marL="0">
+              <a:buNone/>
+              <a:defRPr lang="en-US" sz="1300" b="1" spc="300" kern="0" dirty="0">
+                <a:solidFill>
+                  <a:schemeClr val="accent6"/>
                 </a:solidFill>
               </a:defRPr>
             </a:lvl1pPr>
           </a:lstStyle>
           <a:p>
-            <a:pPr indent="0" marL="0">
-              <a:buNone/>
-            </a:pPr>
-            <a:endParaRPr lang="en-US" sz="1800" dirty="0"/>
+            <a:pPr algn="ctr" indent="0" marL="0">
+              <a:buNone/>
+            </a:pPr>
+            <a:endParaRPr lang="en-US" sz="1300" dirty="0"/>
+          </a:p>
+        </p:txBody>
+      </p:sp>
+      <p:sp>
+        <p:nvSpPr>
+          <p:cNvPr id="5" name="Text 1"/>
+          <p:cNvSpPr/>
+          <p:nvPr>
+            <p:ph idx="103" type="title" hasCustomPrompt="1"/>
+          </p:nvPr>
+        </p:nvSpPr>
+        <p:spPr>
+          <a:xfrm>
+            <a:off x="2514600" y="868680"/>
+            <a:ext cx="6400800" cy="868680"/>
+          </a:xfrm>
+          <a:prstGeom prst="rect">
+            <a:avLst/>
+          </a:prstGeom>
+          <a:noFill/>
+          <a:ln/>
+        </p:spPr>
+        <p:txBody>
+          <a:bodyPr wrap="square" rtlCol="0"/>
+          <a:lstStyle>
+            <a:lvl1pPr algn="ctr" indent="0" marL="0">
+              <a:buNone/>
+              <a:defRPr lang="en-US" sz="3600" b="1" dirty="0">
+                <a:solidFill>
+                  <a:schemeClr val="tx1"/>
+                </a:solidFill>
+              </a:defRPr>
+            </a:lvl1pPr>
+          </a:lstStyle>
+          <a:p>
+            <a:pPr algn="ctr" indent="0" marL="0">
+              <a:buNone/>
+            </a:pPr>
+            <a:endParaRPr lang="en-US" sz="3600" dirty="0"/>
+          </a:p>
+        </p:txBody>
+      </p:sp>
+      <p:sp>
+        <p:nvSpPr>
+          <p:cNvPr id="6" name="Text 1"/>
+          <p:cNvSpPr/>
+          <p:nvPr>
+            <p:ph idx="104" type="body" hasCustomPrompt="1"/>
+          </p:nvPr>
+        </p:nvSpPr>
+        <p:spPr>
+          <a:xfrm>
+            <a:off x="2971800" y="1783080"/>
+            <a:ext cx="5486400" cy="685800"/>
+          </a:xfrm>
+          <a:prstGeom prst="rect">
+            <a:avLst/>
+          </a:prstGeom>
+          <a:noFill/>
+          <a:ln/>
+        </p:spPr>
+        <p:txBody>
+          <a:bodyPr wrap="square" rtlCol="0"/>
+          <a:lstStyle>
+            <a:lvl1pPr algn="ctr" indent="0" marL="0">
+              <a:buNone/>
+              <a:defRPr lang="en-US" sz="1600" dirty="0">
+                <a:solidFill>
+                  <a:schemeClr val="accent4"/>
+                </a:solidFill>
+              </a:defRPr>
+            </a:lvl1pPr>
+          </a:lstStyle>
+          <a:p>
+            <a:pPr algn="ctr" indent="0" marL="0">
+              <a:buNone/>
+            </a:pPr>
+            <a:endParaRPr lang="en-US" sz="1600" dirty="0"/>
           </a:p>
         </p:txBody>
       </p:sp>
@@ -2012,6 +2056,101 @@
 <file path=ppt/slideLayouts/slideLayout3.xml><?xml version="1.0" encoding="utf-8"?>
 <p:sldLayout xmlns:a="http://schemas.openxmlformats.org/drawingml/2006/main" xmlns:r="http://schemas.openxmlformats.org/officeDocument/2006/relationships" xmlns:p="http://schemas.openxmlformats.org/presentationml/2006/main" preserve="1">
   <p:cSld name="CONTENT">
+    <p:bg>
+      <p:bgPr>
+        <a:solidFill>
+          <a:schemeClr val="bg2"/>
+        </a:solidFill>
+      </p:bgPr>
+    </p:bg>
+    <p:spTree>
+      <p:nvGrpSpPr>
+        <p:cNvPr id="1" name=""/>
+        <p:cNvGrpSpPr/>
+        <p:nvPr/>
+      </p:nvGrpSpPr>
+      <p:grpSpPr>
+        <a:xfrm>
+          <a:off x="0" y="0"/>
+          <a:ext cx="0" cy="0"/>
+          <a:chOff x="0" y="0"/>
+          <a:chExt cx="0" cy="0"/>
+        </a:xfrm>
+      </p:grpSpPr>
+      <p:pic>
+        <p:nvPicPr>
+          <p:cNvPr id="2" name="Image 0" descr="preencoded.png">    </p:cNvPr>
+          <p:cNvPicPr>
+            <a:picLocks noChangeAspect="1"/>
+          </p:cNvPicPr>
+          <p:nvPr/>
+        </p:nvPicPr>
+        <p:blipFill>
+          <a:blip r:embed="rId1"/>
+          <a:stretch>
+            <a:fillRect/>
+          </a:stretch>
+        </p:blipFill>
+        <p:spPr>
+          <a:xfrm>
+            <a:off x="201168" y="109728"/>
+            <a:ext cx="1417320" cy="434340"/>
+          </a:xfrm>
+          <a:prstGeom prst="rect">
+            <a:avLst/>
+          </a:prstGeom>
+        </p:spPr>
+      </p:pic>
+      <p:sp>
+        <p:nvSpPr>
+          <p:cNvPr id="3" name="Text 0"/>
+          <p:cNvSpPr/>
+          <p:nvPr>
+            <p:ph idx="101" type="title" hasCustomPrompt="1"/>
+          </p:nvPr>
+        </p:nvSpPr>
+        <p:spPr>
+          <a:xfrm>
+            <a:off x="457200" y="640080"/>
+            <a:ext cx="5394960" cy="548640"/>
+          </a:xfrm>
+          <a:prstGeom prst="rect">
+            <a:avLst/>
+          </a:prstGeom>
+          <a:noFill/>
+          <a:ln/>
+        </p:spPr>
+        <p:txBody>
+          <a:bodyPr wrap="square" rtlCol="0"/>
+          <a:lstStyle>
+            <a:lvl1pPr algn="l" indent="0" marL="0">
+              <a:buNone/>
+              <a:defRPr lang="en-US" sz="2800" b="1" dirty="0">
+                <a:solidFill>
+                  <a:schemeClr val="tx1"/>
+                </a:solidFill>
+              </a:defRPr>
+            </a:lvl1pPr>
+          </a:lstStyle>
+          <a:p>
+            <a:pPr algn="l" indent="0" marL="0">
+              <a:buNone/>
+            </a:pPr>
+            <a:endParaRPr lang="en-US" sz="2800" dirty="0"/>
+          </a:p>
+        </p:txBody>
+      </p:sp>
+    </p:spTree>
+  </p:cSld>
+  <p:clrMapOvr>
+    <a:masterClrMapping/>
+  </p:clrMapOvr>
+</p:sldLayout>
+</file>
+
+<file path=ppt/slideLayouts/slideLayout4.xml><?xml version="1.0" encoding="utf-8"?>
+<p:sldLayout xmlns:a="http://schemas.openxmlformats.org/drawingml/2006/main" xmlns:r="http://schemas.openxmlformats.org/officeDocument/2006/relationships" xmlns:p="http://schemas.openxmlformats.org/presentationml/2006/main" preserve="1">
+  <p:cSld name="CLOSING">
     <p:bg>
       <p:bgPr>
         <a:solidFill>
@@ -2033,90 +2172,30 @@
           <a:chExt cx="0" cy="0"/>
         </a:xfrm>
       </p:grpSpPr>
-      <p:sp>
-        <p:nvSpPr>
-          <p:cNvPr id="2" name="Text 0"/>
-          <p:cNvSpPr/>
-          <p:nvPr>
-            <p:ph idx="100" type="title" hasCustomPrompt="1"/>
-          </p:nvPr>
-        </p:nvSpPr>
-        <p:spPr>
-          <a:xfrm>
-            <a:off x="457200" y="320040"/>
-            <a:ext cx="5394960" cy="685800"/>
-          </a:xfrm>
-          <a:prstGeom prst="rect">
-            <a:avLst/>
-          </a:prstGeom>
-          <a:noFill/>
-          <a:ln/>
-        </p:spPr>
-        <p:txBody>
-          <a:bodyPr wrap="square" rtlCol="0"/>
-          <a:lstStyle>
-            <a:lvl1pPr algn="l" indent="0" marL="0">
-              <a:buNone/>
-              <a:defRPr lang="en-US" sz="3000" b="1" dirty="0">
-                <a:solidFill>
-                  <a:schemeClr val="tx1"/>
-                </a:solidFill>
-              </a:defRPr>
-            </a:lvl1pPr>
-          </a:lstStyle>
-          <a:p>
-            <a:pPr algn="l" indent="0" marL="0">
-              <a:buNone/>
-            </a:pPr>
-            <a:endParaRPr lang="en-US" sz="3000" dirty="0"/>
-          </a:p>
-        </p:txBody>
-      </p:sp>
-      <p:sp>
-        <p:nvSpPr>
-          <p:cNvPr id="25" name="Slide Number Placeholder 0"/>
-          <p:cNvSpPr>
-            <a:spLocks noGrp="1"/>
-          </p:cNvSpPr>
-          <p:nvPr>
-            <p:ph type="sldNum" sz="quarter" idx="4294967295"/>
-          </p:nvPr>
-        </p:nvSpPr>
-        <p:spPr>
-          <a:xfrm>
-            <a:off x="8503920" y="4754880"/>
-            <a:ext cx="365760" cy="274320"/>
-          </a:xfrm>
-          <a:prstGeom prst="rect">
-            <a:avLst/>
-          </a:prstGeom>
-          <a:extLst>
-            <a:ext uri="{C572A759-6A51-4108-AA02-DFA0A04FC94B}">
-              <ma14:wrappingTextBoxFlag xmlns:ma14="http://schemas.microsoft.com/office/mac/drawingml/2011/main" val="0"/>
-            </a:ext>
-          </a:extLst>
-        </p:spPr>
-        <p:txBody>
-          <a:bodyPr/>
-          <a:lstStyle>
-            <a:lvl1pPr>
-              <a:defRPr sz="1000">
-                <a:solidFill>
-                  <a:srgbClr val="8A97A5"/>
-                </a:solidFill>
-              </a:defRPr>
-            </a:lvl1pPr>
-          </a:lstStyle>
-          <a:p>
-            <a:pPr algn="l"/>
-            <a:fld id="{F7021451-1387-4CA6-816F-3879F97B5CBC}" type="slidenum">
-              <a:rPr b="0" lang="en-US"/>
-              <a:t>1003</a:t>
-            </a:fld>
-            <a:endParaRPr lang="en-US"/>
-          </a:p>
-        </p:txBody>
-      </p:sp>
+      <p:pic>
+        <p:nvPicPr>
+          <p:cNvPr id="2" name="Image 0" descr="preencoded.png">    </p:cNvPr>
+          <p:cNvPicPr>
+            <a:picLocks noChangeAspect="1"/>
+          </p:cNvPicPr>
+          <p:nvPr/>
+        </p:nvPicPr>
+        <p:blipFill>
+          <a:blip r:embed="rId1"/>
+          <a:stretch>
+            <a:fillRect/>
+          </a:stretch>
+        </p:blipFill>
+        <p:spPr>
+          <a:xfrm>
+            <a:off x="4023360" y="1234440"/>
+            <a:ext cx="1097280" cy="1225296"/>
+          </a:xfrm>
+          <a:prstGeom prst="rect">
+            <a:avLst/>
+          </a:prstGeom>
+        </p:spPr>
+      </p:pic>
     </p:spTree>
   </p:cSld>
   <p:clrMapOvr>
@@ -2142,51 +2221,6 @@
           <a:chExt cx="0" cy="0"/>
         </a:xfrm>
       </p:grpSpPr>
-      <p:sp>
-        <p:nvSpPr>
-          <p:cNvPr id="25" name="Slide Number Placeholder 0"/>
-          <p:cNvSpPr>
-            <a:spLocks noGrp="1"/>
-          </p:cNvSpPr>
-          <p:nvPr>
-            <p:ph type="sldNum" sz="quarter" idx="4294967295"/>
-          </p:nvPr>
-        </p:nvSpPr>
-        <p:spPr>
-          <a:xfrm>
-            <a:off x="8503920" y="4754880"/>
-            <a:ext cx="365760" cy="274320"/>
-          </a:xfrm>
-          <a:prstGeom prst="rect">
-            <a:avLst/>
-          </a:prstGeom>
-          <a:extLst>
-            <a:ext uri="{C572A759-6A51-4108-AA02-DFA0A04FC94B}">
-              <ma14:wrappingTextBoxFlag xmlns:ma14="http://schemas.microsoft.com/office/mac/drawingml/2011/main" val="0"/>
-            </a:ext>
-          </a:extLst>
-        </p:spPr>
-        <p:txBody>
-          <a:bodyPr/>
-          <a:lstStyle>
-            <a:lvl1pPr>
-              <a:defRPr sz="1000">
-                <a:solidFill>
-                  <a:srgbClr val="8A97A5"/>
-                </a:solidFill>
-              </a:defRPr>
-            </a:lvl1pPr>
-          </a:lstStyle>
-          <a:p>
-            <a:pPr algn="l"/>
-            <a:fld id="{F7021451-1387-4CA6-816F-3879F97B5CBC}" type="slidenum">
-              <a:rPr b="0" lang="en-US"/>
-              <a:t>null</a:t>
-            </a:fld>
-            <a:endParaRPr lang="en-US"/>
-          </a:p>
-        </p:txBody>
-      </p:sp>
     </p:spTree>
   </p:cSld>
   <p:clrMap bg1="lt1" tx1="dk1" bg2="lt2" tx2="dk2" accent1="accent1" accent2="accent2" accent3="accent3" accent4="accent4" accent5="accent5" accent6="accent6" hlink="hlink" folHlink="folHlink"/>
@@ -2194,6 +2228,7 @@
     <p:sldLayoutId id="2147483649" r:id="rId1"/>
     <p:sldLayoutId id="2147483650" r:id="rId2"/>
     <p:sldLayoutId id="2147483651" r:id="rId3"/>
+    <p:sldLayoutId id="2147483652" r:id="rId4"/>
   </p:sldLayoutIdLst>
   <p:hf sldNum="0" hdr="0" ftr="0" dt="0"/>
   <p:txStyles>
@@ -2468,83 +2503,7 @@
       </p:grpSpPr>
       <p:sp>
         <p:nvSpPr>
-          <p:cNvPr id="2" name="Text 0"/>
-          <p:cNvSpPr/>
-          <p:nvPr>
-            <p:ph idx="100" type="body" hasCustomPrompt="1"/>
-          </p:nvPr>
-        </p:nvSpPr>
-        <p:spPr>
-          <a:xfrm>
-            <a:off x="457200" y="1143000"/>
-            <a:ext cx="5394960" cy="365760"/>
-          </a:xfrm>
-          <a:prstGeom prst="rect">
-            <a:avLst/>
-          </a:prstGeom>
-          <a:noFill/>
-          <a:ln/>
-        </p:spPr>
-        <p:txBody>
-          <a:bodyPr wrap="square" lIns="0" tIns="0" rIns="0" bIns="0" rtlCol="0"/>
-          <a:lstStyle/>
-          <a:p>
-            <a:pPr indent="0" marL="0">
-              <a:buNone/>
-            </a:pPr>
-            <a:r>
-              <a:rPr lang="en-US" sz="1400" b="1" spc="300" kern="0" dirty="0">
-                <a:solidFill>
-                  <a:schemeClr val="accent1"/>
-                </a:solidFill>
-              </a:rPr>
-              <a:t>wAPMT COACHING CAMPAIGN</a:t>
-            </a:r>
-            <a:endParaRPr lang="en-US" sz="1400" dirty="0"/>
-          </a:p>
-        </p:txBody>
-      </p:sp>
-      <p:sp>
-        <p:nvSpPr>
-          <p:cNvPr id="3" name="Text 0"/>
-          <p:cNvSpPr/>
-          <p:nvPr>
-            <p:ph idx="101" type="title" hasCustomPrompt="1"/>
-          </p:nvPr>
-        </p:nvSpPr>
-        <p:spPr>
-          <a:xfrm>
-            <a:off x="457200" y="1554480"/>
-            <a:ext cx="5394960" cy="1463040"/>
-          </a:xfrm>
-          <a:prstGeom prst="rect">
-            <a:avLst/>
-          </a:prstGeom>
-          <a:noFill/>
-          <a:ln/>
-        </p:spPr>
-        <p:txBody>
-          <a:bodyPr wrap="square" lIns="0" tIns="0" rIns="0" bIns="0" rtlCol="0" anchor="t"/>
-          <a:lstStyle/>
-          <a:p>
-            <a:pPr algn="l" indent="0" marL="0">
-              <a:buNone/>
-            </a:pPr>
-            <a:r>
-              <a:rPr lang="en-US" sz="4000" b="1" dirty="0">
-                <a:solidFill>
-                  <a:schemeClr val="bg1"/>
-                </a:solidFill>
-              </a:rPr>
-              <a:t>Every Bin, Every Time</a:t>
-            </a:r>
-            <a:endParaRPr lang="en-US" sz="4000" dirty="0"/>
-          </a:p>
-        </p:txBody>
-      </p:sp>
-      <p:sp>
-        <p:nvSpPr>
-          <p:cNvPr id="4" name="Text 0"/>
+          <p:cNvPr id="2" name="Text 1"/>
           <p:cNvSpPr/>
           <p:nvPr>
             <p:ph idx="102" type="body" hasCustomPrompt="1"/>
@@ -2552,8 +2511,84 @@
         </p:nvSpPr>
         <p:spPr>
           <a:xfrm>
-            <a:off x="457200" y="3063240"/>
-            <a:ext cx="4846320" cy="822960"/>
+            <a:off x="2514600" y="502920"/>
+            <a:ext cx="6400800" cy="320040"/>
+          </a:xfrm>
+          <a:prstGeom prst="rect">
+            <a:avLst/>
+          </a:prstGeom>
+          <a:noFill/>
+          <a:ln/>
+        </p:spPr>
+        <p:txBody>
+          <a:bodyPr wrap="square" lIns="0" tIns="0" rIns="0" bIns="0" rtlCol="0"/>
+          <a:lstStyle/>
+          <a:p>
+            <a:pPr algn="ctr" indent="0" marL="0">
+              <a:buNone/>
+            </a:pPr>
+            <a:r>
+              <a:rPr lang="en-US" sz="1300" b="1" spc="300" kern="0" dirty="0">
+                <a:solidFill>
+                  <a:schemeClr val="accent6"/>
+                </a:solidFill>
+              </a:rPr>
+              <a:t>wAPMT COACHING CAMPAIGN</a:t>
+            </a:r>
+            <a:endParaRPr lang="en-US" sz="1300" dirty="0"/>
+          </a:p>
+        </p:txBody>
+      </p:sp>
+      <p:sp>
+        <p:nvSpPr>
+          <p:cNvPr id="3" name="Text 1"/>
+          <p:cNvSpPr/>
+          <p:nvPr>
+            <p:ph idx="103" type="title" hasCustomPrompt="1"/>
+          </p:nvPr>
+        </p:nvSpPr>
+        <p:spPr>
+          <a:xfrm>
+            <a:off x="2514600" y="868680"/>
+            <a:ext cx="6400800" cy="868680"/>
+          </a:xfrm>
+          <a:prstGeom prst="rect">
+            <a:avLst/>
+          </a:prstGeom>
+          <a:noFill/>
+          <a:ln/>
+        </p:spPr>
+        <p:txBody>
+          <a:bodyPr wrap="square" lIns="0" tIns="0" rIns="0" bIns="0" rtlCol="0" anchor="ctr"/>
+          <a:lstStyle/>
+          <a:p>
+            <a:pPr algn="ctr" indent="0" marL="0">
+              <a:buNone/>
+            </a:pPr>
+            <a:r>
+              <a:rPr lang="en-US" sz="3600" b="1" dirty="0">
+                <a:solidFill>
+                  <a:schemeClr val="tx1"/>
+                </a:solidFill>
+              </a:rPr>
+              <a:t>Every Bin, Every Time</a:t>
+            </a:r>
+            <a:endParaRPr lang="en-US" sz="3600" dirty="0"/>
+          </a:p>
+        </p:txBody>
+      </p:sp>
+      <p:sp>
+        <p:nvSpPr>
+          <p:cNvPr id="4" name="Text 1"/>
+          <p:cNvSpPr/>
+          <p:nvPr>
+            <p:ph idx="104" type="body" hasCustomPrompt="1"/>
+          </p:nvPr>
+        </p:nvSpPr>
+        <p:spPr>
+          <a:xfrm>
+            <a:off x="2971800" y="1783080"/>
+            <a:ext cx="5486400" cy="685800"/>
           </a:xfrm>
           <a:prstGeom prst="rect">
             <a:avLst/>
@@ -2565,45 +2600,21 @@
           <a:bodyPr wrap="square" lIns="0" tIns="0" rIns="0" bIns="0" rtlCol="0" anchor="t"/>
           <a:lstStyle/>
           <a:p>
-            <a:pPr indent="0" marL="0">
-              <a:buNone/>
-            </a:pPr>
-            <a:r>
-              <a:rPr lang="en-US" sz="1800" dirty="0">
-                <a:solidFill>
-                  <a:srgbClr val="C9D3DD"/>
+            <a:pPr algn="ctr" indent="0" marL="0">
+              <a:buNone/>
+            </a:pPr>
+            <a:r>
+              <a:rPr lang="en-US" sz="1600" dirty="0">
+                <a:solidFill>
+                  <a:schemeClr val="accent4"/>
                 </a:solidFill>
               </a:rPr>
               <a:t>First Face Fix and the ROBOTSS rules: two habits that stop amnesty at the source</a:t>
             </a:r>
-            <a:endParaRPr lang="en-US" sz="1800" dirty="0"/>
-          </a:p>
-        </p:txBody>
-      </p:sp>
-      <p:pic>
-        <p:nvPicPr>
-          <p:cNvPr id="5" name="Title icon" descr="preencoded.png">    </p:cNvPr>
-          <p:cNvPicPr>
-            <a:picLocks noChangeAspect="1"/>
-          </p:cNvPicPr>
-          <p:nvPr/>
-        </p:nvPicPr>
-        <p:blipFill>
-          <a:blip r:embed="rId1"/>
-          <a:stretch>
-            <a:fillRect/>
-          </a:stretch>
-        </p:blipFill>
-        <p:spPr>
-          <a:xfrm>
-            <a:off x="457200" y="457200"/>
-            <a:ext cx="502920" cy="502920"/>
-          </a:xfrm>
-          <a:prstGeom prst="rect">
-            <a:avLst/>
-          </a:prstGeom>
-        </p:spPr>
-      </p:pic>
+            <a:endParaRPr lang="en-US" sz="1600" dirty="0"/>
+          </a:p>
+        </p:txBody>
+      </p:sp>
     </p:spTree>
   </p:cSld>
   <p:clrMapOvr>
@@ -2634,13 +2645,13 @@
           <p:cNvPr id="2" name="Text 0"/>
           <p:cNvSpPr/>
           <p:nvPr>
-            <p:ph idx="100" type="title" hasCustomPrompt="1"/>
+            <p:ph idx="101" type="title" hasCustomPrompt="1"/>
           </p:nvPr>
         </p:nvSpPr>
         <p:spPr>
           <a:xfrm>
-            <a:off x="457200" y="320040"/>
-            <a:ext cx="5394960" cy="685800"/>
+            <a:off x="457200" y="640080"/>
+            <a:ext cx="5394960" cy="548640"/>
           </a:xfrm>
           <a:prstGeom prst="rect">
             <a:avLst/>
@@ -2656,14 +2667,14 @@
               <a:buNone/>
             </a:pPr>
             <a:r>
-              <a:rPr lang="en-US" sz="3000" b="1" dirty="0">
+              <a:rPr lang="en-US" sz="2800" b="1" dirty="0">
                 <a:solidFill>
                   <a:schemeClr val="tx1"/>
                 </a:solidFill>
               </a:rPr>
               <a:t>Seven rules, one word</a:t>
             </a:r>
-            <a:endParaRPr lang="en-US" sz="3000" dirty="0"/>
+            <a:endParaRPr lang="en-US" sz="2800" dirty="0"/>
           </a:p>
         </p:txBody>
       </p:sp>
@@ -2680,7 +2691,7 @@
           </a:xfrm>
           <a:prstGeom prst="roundRect">
             <a:avLst>
-              <a:gd name="adj" fmla="val 10811"/>
+              <a:gd name="adj" fmla="val 13514"/>
             </a:avLst>
           </a:prstGeom>
           <a:solidFill>
@@ -2777,7 +2788,7 @@
           </a:xfrm>
           <a:prstGeom prst="roundRect">
             <a:avLst>
-              <a:gd name="adj" fmla="val 10811"/>
+              <a:gd name="adj" fmla="val 13514"/>
             </a:avLst>
           </a:prstGeom>
           <a:solidFill>
@@ -2874,7 +2885,7 @@
           </a:xfrm>
           <a:prstGeom prst="roundRect">
             <a:avLst>
-              <a:gd name="adj" fmla="val 10811"/>
+              <a:gd name="adj" fmla="val 13514"/>
             </a:avLst>
           </a:prstGeom>
           <a:solidFill>
@@ -2971,7 +2982,7 @@
           </a:xfrm>
           <a:prstGeom prst="roundRect">
             <a:avLst>
-              <a:gd name="adj" fmla="val 10811"/>
+              <a:gd name="adj" fmla="val 13514"/>
             </a:avLst>
           </a:prstGeom>
           <a:solidFill>
@@ -3068,7 +3079,7 @@
           </a:xfrm>
           <a:prstGeom prst="roundRect">
             <a:avLst>
-              <a:gd name="adj" fmla="val 10811"/>
+              <a:gd name="adj" fmla="val 13514"/>
             </a:avLst>
           </a:prstGeom>
           <a:solidFill>
@@ -3165,7 +3176,7 @@
           </a:xfrm>
           <a:prstGeom prst="roundRect">
             <a:avLst>
-              <a:gd name="adj" fmla="val 10811"/>
+              <a:gd name="adj" fmla="val 13514"/>
             </a:avLst>
           </a:prstGeom>
           <a:solidFill>
@@ -3262,7 +3273,7 @@
           </a:xfrm>
           <a:prstGeom prst="roundRect">
             <a:avLst>
-              <a:gd name="adj" fmla="val 10811"/>
+              <a:gd name="adj" fmla="val 13514"/>
             </a:avLst>
           </a:prstGeom>
           <a:solidFill>
@@ -3354,16 +3365,16 @@
         </p:nvSpPr>
         <p:spPr>
           <a:xfrm>
-            <a:off x="457200" y="3291840"/>
-            <a:ext cx="5394960" cy="1143000"/>
+            <a:off x="457200" y="3429000"/>
+            <a:ext cx="5394960" cy="1097280"/>
           </a:xfrm>
           <a:prstGeom prst="roundRect">
             <a:avLst>
-              <a:gd name="adj" fmla="val 8000"/>
+              <a:gd name="adj" fmla="val 8333"/>
             </a:avLst>
           </a:prstGeom>
           <a:solidFill>
-            <a:schemeClr val="bg2"/>
+            <a:schemeClr val="bg1"/>
           </a:solidFill>
           <a:ln/>
         </p:spPr>
@@ -3376,8 +3387,8 @@
         </p:nvSpPr>
         <p:spPr>
           <a:xfrm>
-            <a:off x="731520" y="3291840"/>
-            <a:ext cx="4846320" cy="1143000"/>
+            <a:off x="731520" y="3429000"/>
+            <a:ext cx="4846320" cy="1097280"/>
           </a:xfrm>
           <a:prstGeom prst="rect">
             <a:avLst/>
@@ -3412,51 +3423,6 @@
               <a:t>pickers find items faster, bins hold more, and nothing falls out when the pod moves.</a:t>
             </a:r>
             <a:endParaRPr lang="en-US" sz="1500" dirty="0"/>
-          </a:p>
-        </p:txBody>
-      </p:sp>
-      <p:sp>
-        <p:nvSpPr>
-          <p:cNvPr id="25" name="Slide Number Placeholder 0"/>
-          <p:cNvSpPr>
-            <a:spLocks noGrp="1"/>
-          </p:cNvSpPr>
-          <p:nvPr>
-            <p:ph type="sldNum" sz="quarter" idx="4294967295"/>
-          </p:nvPr>
-        </p:nvSpPr>
-        <p:spPr>
-          <a:xfrm>
-            <a:off x="8503920" y="4754880"/>
-            <a:ext cx="365760" cy="274320"/>
-          </a:xfrm>
-          <a:prstGeom prst="rect">
-            <a:avLst/>
-          </a:prstGeom>
-          <a:extLst>
-            <a:ext uri="{C572A759-6A51-4108-AA02-DFA0A04FC94B}">
-              <ma14:wrappingTextBoxFlag xmlns:ma14="http://schemas.microsoft.com/office/mac/drawingml/2011/main" val="0"/>
-            </a:ext>
-          </a:extLst>
-        </p:spPr>
-        <p:txBody>
-          <a:bodyPr/>
-          <a:lstStyle>
-            <a:lvl1pPr>
-              <a:defRPr sz="1000">
-                <a:solidFill>
-                  <a:srgbClr val="8A97A5"/>
-                </a:solidFill>
-              </a:defRPr>
-            </a:lvl1pPr>
-          </a:lstStyle>
-          <a:p>
-            <a:pPr algn="l"/>
-            <a:fld id="{F7021451-1387-4CA6-816F-3879F97B5CBC}" type="slidenum">
-              <a:rPr b="0" lang="en-US"/>
-              <a:t>10</a:t>
-            </a:fld>
-            <a:endParaRPr lang="en-US"/>
           </a:p>
         </p:txBody>
       </p:sp>
@@ -3490,13 +3456,13 @@
           <p:cNvPr id="2" name="Text 0"/>
           <p:cNvSpPr/>
           <p:nvPr>
-            <p:ph idx="100" type="title" hasCustomPrompt="1"/>
+            <p:ph idx="101" type="title" hasCustomPrompt="1"/>
           </p:nvPr>
         </p:nvSpPr>
         <p:spPr>
           <a:xfrm>
-            <a:off x="457200" y="320040"/>
-            <a:ext cx="5394960" cy="685800"/>
+            <a:off x="457200" y="640080"/>
+            <a:ext cx="5394960" cy="548640"/>
           </a:xfrm>
           <a:prstGeom prst="rect">
             <a:avLst/>
@@ -3512,14 +3478,14 @@
               <a:buNone/>
             </a:pPr>
             <a:r>
-              <a:rPr lang="en-US" sz="3000" b="1" dirty="0">
+              <a:rPr lang="en-US" sz="2800" b="1" dirty="0">
                 <a:solidFill>
                   <a:schemeClr val="tx1"/>
                 </a:solidFill>
               </a:rPr>
               <a:t>R + O: size it right</a:t>
             </a:r>
-            <a:endParaRPr lang="en-US" sz="3000" dirty="0"/>
+            <a:endParaRPr lang="en-US" sz="2800" dirty="0"/>
           </a:p>
         </p:txBody>
       </p:sp>
@@ -3531,8 +3497,8 @@
         </p:nvSpPr>
         <p:spPr>
           <a:xfrm>
-            <a:off x="457200" y="1143000"/>
-            <a:ext cx="2606040" cy="3337560"/>
+            <a:off x="457200" y="1325880"/>
+            <a:ext cx="2606040" cy="3200400"/>
           </a:xfrm>
           <a:prstGeom prst="roundRect">
             <a:avLst>
@@ -3540,7 +3506,7 @@
             </a:avLst>
           </a:prstGeom>
           <a:solidFill>
-            <a:schemeClr val="bg2"/>
+            <a:schemeClr val="bg1"/>
           </a:solidFill>
           <a:ln/>
         </p:spPr>
@@ -3553,7 +3519,7 @@
         </p:nvSpPr>
         <p:spPr>
           <a:xfrm>
-            <a:off x="685800" y="1371600"/>
+            <a:off x="685800" y="1554480"/>
             <a:ext cx="731520" cy="731520"/>
           </a:xfrm>
           <a:prstGeom prst="ellipse">
@@ -3573,7 +3539,7 @@
         </p:nvSpPr>
         <p:spPr>
           <a:xfrm>
-            <a:off x="685800" y="1371600"/>
+            <a:off x="685800" y="1554480"/>
             <a:ext cx="731520" cy="731520"/>
           </a:xfrm>
           <a:prstGeom prst="rect">
@@ -3612,7 +3578,7 @@
         </p:nvSpPr>
         <p:spPr>
           <a:xfrm>
-            <a:off x="685800" y="2240280"/>
+            <a:off x="685800" y="2423160"/>
             <a:ext cx="2194560" cy="411480"/>
           </a:xfrm>
           <a:prstGeom prst="rect">
@@ -3648,8 +3614,8 @@
         </p:nvSpPr>
         <p:spPr>
           <a:xfrm>
-            <a:off x="685800" y="2743200"/>
-            <a:ext cx="2240280" cy="1600200"/>
+            <a:off x="685800" y="2926080"/>
+            <a:ext cx="2240280" cy="1508760"/>
           </a:xfrm>
           <a:prstGeom prst="rect">
             <a:avLst/>
@@ -3706,8 +3672,8 @@
         </p:nvSpPr>
         <p:spPr>
           <a:xfrm>
-            <a:off x="3246120" y="1143000"/>
-            <a:ext cx="2606040" cy="3337560"/>
+            <a:off x="3246120" y="1325880"/>
+            <a:ext cx="2606040" cy="3200400"/>
           </a:xfrm>
           <a:prstGeom prst="roundRect">
             <a:avLst>
@@ -3715,7 +3681,7 @@
             </a:avLst>
           </a:prstGeom>
           <a:solidFill>
-            <a:schemeClr val="bg2"/>
+            <a:schemeClr val="bg1"/>
           </a:solidFill>
           <a:ln/>
         </p:spPr>
@@ -3728,7 +3694,7 @@
         </p:nvSpPr>
         <p:spPr>
           <a:xfrm>
-            <a:off x="3474720" y="1371600"/>
+            <a:off x="3474720" y="1554480"/>
             <a:ext cx="731520" cy="731520"/>
           </a:xfrm>
           <a:prstGeom prst="ellipse">
@@ -3748,7 +3714,7 @@
         </p:nvSpPr>
         <p:spPr>
           <a:xfrm>
-            <a:off x="3474720" y="1371600"/>
+            <a:off x="3474720" y="1554480"/>
             <a:ext cx="731520" cy="731520"/>
           </a:xfrm>
           <a:prstGeom prst="rect">
@@ -3787,7 +3753,7 @@
         </p:nvSpPr>
         <p:spPr>
           <a:xfrm>
-            <a:off x="3474720" y="2240280"/>
+            <a:off x="3474720" y="2423160"/>
             <a:ext cx="2194560" cy="411480"/>
           </a:xfrm>
           <a:prstGeom prst="rect">
@@ -3823,8 +3789,8 @@
         </p:nvSpPr>
         <p:spPr>
           <a:xfrm>
-            <a:off x="3474720" y="2743200"/>
-            <a:ext cx="2240280" cy="1600200"/>
+            <a:off x="3474720" y="2926080"/>
+            <a:ext cx="2240280" cy="1508760"/>
           </a:xfrm>
           <a:prstGeom prst="rect">
             <a:avLst/>
@@ -3870,51 +3836,6 @@
               <a:t>Overhang causes drive obstructions and pod crashes</a:t>
             </a:r>
             <a:endParaRPr lang="en-US" sz="1400" dirty="0"/>
-          </a:p>
-        </p:txBody>
-      </p:sp>
-      <p:sp>
-        <p:nvSpPr>
-          <p:cNvPr id="25" name="Slide Number Placeholder 0"/>
-          <p:cNvSpPr>
-            <a:spLocks noGrp="1"/>
-          </p:cNvSpPr>
-          <p:nvPr>
-            <p:ph type="sldNum" sz="quarter" idx="4294967295"/>
-          </p:nvPr>
-        </p:nvSpPr>
-        <p:spPr>
-          <a:xfrm>
-            <a:off x="8503920" y="4754880"/>
-            <a:ext cx="365760" cy="274320"/>
-          </a:xfrm>
-          <a:prstGeom prst="rect">
-            <a:avLst/>
-          </a:prstGeom>
-          <a:extLst>
-            <a:ext uri="{C572A759-6A51-4108-AA02-DFA0A04FC94B}">
-              <ma14:wrappingTextBoxFlag xmlns:ma14="http://schemas.microsoft.com/office/mac/drawingml/2011/main" val="0"/>
-            </a:ext>
-          </a:extLst>
-        </p:spPr>
-        <p:txBody>
-          <a:bodyPr/>
-          <a:lstStyle>
-            <a:lvl1pPr>
-              <a:defRPr sz="1000">
-                <a:solidFill>
-                  <a:srgbClr val="8A97A5"/>
-                </a:solidFill>
-              </a:defRPr>
-            </a:lvl1pPr>
-          </a:lstStyle>
-          <a:p>
-            <a:pPr algn="l"/>
-            <a:fld id="{F7021451-1387-4CA6-816F-3879F97B5CBC}" type="slidenum">
-              <a:rPr b="0" lang="en-US"/>
-              <a:t>11</a:t>
-            </a:fld>
-            <a:endParaRPr lang="en-US"/>
           </a:p>
         </p:txBody>
       </p:sp>
@@ -3948,13 +3869,13 @@
           <p:cNvPr id="2" name="Text 0"/>
           <p:cNvSpPr/>
           <p:nvPr>
-            <p:ph idx="100" type="title" hasCustomPrompt="1"/>
+            <p:ph idx="101" type="title" hasCustomPrompt="1"/>
           </p:nvPr>
         </p:nvSpPr>
         <p:spPr>
           <a:xfrm>
-            <a:off x="457200" y="320040"/>
-            <a:ext cx="5394960" cy="685800"/>
+            <a:off x="457200" y="640080"/>
+            <a:ext cx="5394960" cy="548640"/>
           </a:xfrm>
           <a:prstGeom prst="rect">
             <a:avLst/>
@@ -3970,14 +3891,14 @@
               <a:buNone/>
             </a:pPr>
             <a:r>
-              <a:rPr lang="en-US" sz="3000" b="1" dirty="0">
+              <a:rPr lang="en-US" sz="2800" b="1" dirty="0">
                 <a:solidFill>
                   <a:schemeClr val="tx1"/>
                 </a:solidFill>
               </a:rPr>
               <a:t>B + O: keep items safe</a:t>
             </a:r>
-            <a:endParaRPr lang="en-US" sz="3000" dirty="0"/>
+            <a:endParaRPr lang="en-US" sz="2800" dirty="0"/>
           </a:p>
         </p:txBody>
       </p:sp>
@@ -3989,8 +3910,8 @@
         </p:nvSpPr>
         <p:spPr>
           <a:xfrm>
-            <a:off x="457200" y="1143000"/>
-            <a:ext cx="2606040" cy="3337560"/>
+            <a:off x="457200" y="1325880"/>
+            <a:ext cx="2606040" cy="3200400"/>
           </a:xfrm>
           <a:prstGeom prst="roundRect">
             <a:avLst>
@@ -3998,7 +3919,7 @@
             </a:avLst>
           </a:prstGeom>
           <a:solidFill>
-            <a:schemeClr val="bg2"/>
+            <a:schemeClr val="bg1"/>
           </a:solidFill>
           <a:ln/>
         </p:spPr>
@@ -4011,7 +3932,7 @@
         </p:nvSpPr>
         <p:spPr>
           <a:xfrm>
-            <a:off x="685800" y="1371600"/>
+            <a:off x="685800" y="1554480"/>
             <a:ext cx="731520" cy="731520"/>
           </a:xfrm>
           <a:prstGeom prst="ellipse">
@@ -4031,7 +3952,7 @@
         </p:nvSpPr>
         <p:spPr>
           <a:xfrm>
-            <a:off x="685800" y="1371600"/>
+            <a:off x="685800" y="1554480"/>
             <a:ext cx="731520" cy="731520"/>
           </a:xfrm>
           <a:prstGeom prst="rect">
@@ -4070,7 +3991,7 @@
         </p:nvSpPr>
         <p:spPr>
           <a:xfrm>
-            <a:off x="685800" y="2240280"/>
+            <a:off x="685800" y="2423160"/>
             <a:ext cx="2194560" cy="411480"/>
           </a:xfrm>
           <a:prstGeom prst="rect">
@@ -4106,8 +4027,8 @@
         </p:nvSpPr>
         <p:spPr>
           <a:xfrm>
-            <a:off x="685800" y="2743200"/>
-            <a:ext cx="2240280" cy="1600200"/>
+            <a:off x="685800" y="2926080"/>
+            <a:ext cx="2240280" cy="1508760"/>
           </a:xfrm>
           <a:prstGeom prst="rect">
             <a:avLst/>
@@ -4164,8 +4085,8 @@
         </p:nvSpPr>
         <p:spPr>
           <a:xfrm>
-            <a:off x="3246120" y="1143000"/>
-            <a:ext cx="2606040" cy="3337560"/>
+            <a:off x="3246120" y="1325880"/>
+            <a:ext cx="2606040" cy="3200400"/>
           </a:xfrm>
           <a:prstGeom prst="roundRect">
             <a:avLst>
@@ -4173,7 +4094,7 @@
             </a:avLst>
           </a:prstGeom>
           <a:solidFill>
-            <a:schemeClr val="bg2"/>
+            <a:schemeClr val="bg1"/>
           </a:solidFill>
           <a:ln/>
         </p:spPr>
@@ -4186,7 +4107,7 @@
         </p:nvSpPr>
         <p:spPr>
           <a:xfrm>
-            <a:off x="3474720" y="1371600"/>
+            <a:off x="3474720" y="1554480"/>
             <a:ext cx="731520" cy="731520"/>
           </a:xfrm>
           <a:prstGeom prst="ellipse">
@@ -4206,7 +4127,7 @@
         </p:nvSpPr>
         <p:spPr>
           <a:xfrm>
-            <a:off x="3474720" y="1371600"/>
+            <a:off x="3474720" y="1554480"/>
             <a:ext cx="731520" cy="731520"/>
           </a:xfrm>
           <a:prstGeom prst="rect">
@@ -4245,7 +4166,7 @@
         </p:nvSpPr>
         <p:spPr>
           <a:xfrm>
-            <a:off x="3474720" y="2240280"/>
+            <a:off x="3474720" y="2423160"/>
             <a:ext cx="2194560" cy="411480"/>
           </a:xfrm>
           <a:prstGeom prst="rect">
@@ -4281,8 +4202,8 @@
         </p:nvSpPr>
         <p:spPr>
           <a:xfrm>
-            <a:off x="3474720" y="2743200"/>
-            <a:ext cx="2240280" cy="1600200"/>
+            <a:off x="3474720" y="2926080"/>
+            <a:ext cx="2240280" cy="1508760"/>
           </a:xfrm>
           <a:prstGeom prst="rect">
             <a:avLst/>
@@ -4328,51 +4249,6 @@
               <a:t>Forcing items in damages customer products</a:t>
             </a:r>
             <a:endParaRPr lang="en-US" sz="1400" dirty="0"/>
-          </a:p>
-        </p:txBody>
-      </p:sp>
-      <p:sp>
-        <p:nvSpPr>
-          <p:cNvPr id="25" name="Slide Number Placeholder 0"/>
-          <p:cNvSpPr>
-            <a:spLocks noGrp="1"/>
-          </p:cNvSpPr>
-          <p:nvPr>
-            <p:ph type="sldNum" sz="quarter" idx="4294967295"/>
-          </p:nvPr>
-        </p:nvSpPr>
-        <p:spPr>
-          <a:xfrm>
-            <a:off x="8503920" y="4754880"/>
-            <a:ext cx="365760" cy="274320"/>
-          </a:xfrm>
-          <a:prstGeom prst="rect">
-            <a:avLst/>
-          </a:prstGeom>
-          <a:extLst>
-            <a:ext uri="{C572A759-6A51-4108-AA02-DFA0A04FC94B}">
-              <ma14:wrappingTextBoxFlag xmlns:ma14="http://schemas.microsoft.com/office/mac/drawingml/2011/main" val="0"/>
-            </a:ext>
-          </a:extLst>
-        </p:spPr>
-        <p:txBody>
-          <a:bodyPr/>
-          <a:lstStyle>
-            <a:lvl1pPr>
-              <a:defRPr sz="1000">
-                <a:solidFill>
-                  <a:srgbClr val="8A97A5"/>
-                </a:solidFill>
-              </a:defRPr>
-            </a:lvl1pPr>
-          </a:lstStyle>
-          <a:p>
-            <a:pPr algn="l"/>
-            <a:fld id="{F7021451-1387-4CA6-816F-3879F97B5CBC}" type="slidenum">
-              <a:rPr b="0" lang="en-US"/>
-              <a:t>12</a:t>
-            </a:fld>
-            <a:endParaRPr lang="en-US"/>
           </a:p>
         </p:txBody>
       </p:sp>
@@ -4406,13 +4282,13 @@
           <p:cNvPr id="2" name="Text 0"/>
           <p:cNvSpPr/>
           <p:nvPr>
-            <p:ph idx="100" type="title" hasCustomPrompt="1"/>
+            <p:ph idx="101" type="title" hasCustomPrompt="1"/>
           </p:nvPr>
         </p:nvSpPr>
         <p:spPr>
           <a:xfrm>
-            <a:off x="457200" y="320040"/>
-            <a:ext cx="5394960" cy="685800"/>
+            <a:off x="457200" y="640080"/>
+            <a:ext cx="5394960" cy="548640"/>
           </a:xfrm>
           <a:prstGeom prst="rect">
             <a:avLst/>
@@ -4428,14 +4304,14 @@
               <a:buNone/>
             </a:pPr>
             <a:r>
-              <a:rPr lang="en-US" sz="3000" b="1" dirty="0">
+              <a:rPr lang="en-US" sz="2800" b="1" dirty="0">
                 <a:solidFill>
                   <a:schemeClr val="tx1"/>
                 </a:solidFill>
               </a:rPr>
               <a:t>T + S + S: easy to pick</a:t>
             </a:r>
-            <a:endParaRPr lang="en-US" sz="3000" dirty="0"/>
+            <a:endParaRPr lang="en-US" sz="2800" dirty="0"/>
           </a:p>
         </p:txBody>
       </p:sp>
@@ -4447,16 +4323,16 @@
         </p:nvSpPr>
         <p:spPr>
           <a:xfrm>
-            <a:off x="457200" y="1143000"/>
-            <a:ext cx="5394960" cy="1005840"/>
+            <a:off x="457200" y="1325880"/>
+            <a:ext cx="5394960" cy="960120"/>
           </a:xfrm>
           <a:prstGeom prst="roundRect">
             <a:avLst>
-              <a:gd name="adj" fmla="val 9091"/>
+              <a:gd name="adj" fmla="val 9524"/>
             </a:avLst>
           </a:prstGeom>
           <a:solidFill>
-            <a:schemeClr val="bg2"/>
+            <a:schemeClr val="bg1"/>
           </a:solidFill>
           <a:ln/>
         </p:spPr>
@@ -4469,8 +4345,8 @@
         </p:nvSpPr>
         <p:spPr>
           <a:xfrm>
-            <a:off x="640080" y="1307592"/>
-            <a:ext cx="676656" cy="676656"/>
+            <a:off x="640080" y="1472184"/>
+            <a:ext cx="658368" cy="658368"/>
           </a:xfrm>
           <a:prstGeom prst="ellipse">
             <a:avLst/>
@@ -4489,8 +4365,8 @@
         </p:nvSpPr>
         <p:spPr>
           <a:xfrm>
-            <a:off x="640080" y="1307592"/>
-            <a:ext cx="676656" cy="676656"/>
+            <a:off x="640080" y="1472184"/>
+            <a:ext cx="658368" cy="658368"/>
           </a:xfrm>
           <a:prstGeom prst="rect">
             <a:avLst/>
@@ -4528,8 +4404,8 @@
         </p:nvSpPr>
         <p:spPr>
           <a:xfrm>
-            <a:off x="1554480" y="1143000"/>
-            <a:ext cx="4114800" cy="1005840"/>
+            <a:off x="1554480" y="1325880"/>
+            <a:ext cx="4114800" cy="960120"/>
           </a:xfrm>
           <a:prstGeom prst="rect">
             <a:avLst/>
@@ -4578,16 +4454,16 @@
         </p:nvSpPr>
         <p:spPr>
           <a:xfrm>
-            <a:off x="457200" y="2286000"/>
-            <a:ext cx="5394960" cy="1005840"/>
+            <a:off x="457200" y="2423160"/>
+            <a:ext cx="5394960" cy="960120"/>
           </a:xfrm>
           <a:prstGeom prst="roundRect">
             <a:avLst>
-              <a:gd name="adj" fmla="val 9091"/>
+              <a:gd name="adj" fmla="val 9524"/>
             </a:avLst>
           </a:prstGeom>
           <a:solidFill>
-            <a:schemeClr val="bg2"/>
+            <a:schemeClr val="bg1"/>
           </a:solidFill>
           <a:ln/>
         </p:spPr>
@@ -4600,8 +4476,8 @@
         </p:nvSpPr>
         <p:spPr>
           <a:xfrm>
-            <a:off x="640080" y="2450592"/>
-            <a:ext cx="676656" cy="676656"/>
+            <a:off x="640080" y="2569464"/>
+            <a:ext cx="658368" cy="658368"/>
           </a:xfrm>
           <a:prstGeom prst="ellipse">
             <a:avLst/>
@@ -4620,8 +4496,8 @@
         </p:nvSpPr>
         <p:spPr>
           <a:xfrm>
-            <a:off x="640080" y="2450592"/>
-            <a:ext cx="676656" cy="676656"/>
+            <a:off x="640080" y="2569464"/>
+            <a:ext cx="658368" cy="658368"/>
           </a:xfrm>
           <a:prstGeom prst="rect">
             <a:avLst/>
@@ -4659,8 +4535,8 @@
         </p:nvSpPr>
         <p:spPr>
           <a:xfrm>
-            <a:off x="1554480" y="2286000"/>
-            <a:ext cx="4114800" cy="1005840"/>
+            <a:off x="1554480" y="2423160"/>
+            <a:ext cx="4114800" cy="960120"/>
           </a:xfrm>
           <a:prstGeom prst="rect">
             <a:avLst/>
@@ -4709,16 +4585,16 @@
         </p:nvSpPr>
         <p:spPr>
           <a:xfrm>
-            <a:off x="457200" y="3429000"/>
-            <a:ext cx="5394960" cy="1005840"/>
+            <a:off x="457200" y="3520440"/>
+            <a:ext cx="5394960" cy="960120"/>
           </a:xfrm>
           <a:prstGeom prst="roundRect">
             <a:avLst>
-              <a:gd name="adj" fmla="val 9091"/>
+              <a:gd name="adj" fmla="val 9524"/>
             </a:avLst>
           </a:prstGeom>
           <a:solidFill>
-            <a:schemeClr val="bg2"/>
+            <a:schemeClr val="bg1"/>
           </a:solidFill>
           <a:ln/>
         </p:spPr>
@@ -4731,8 +4607,8 @@
         </p:nvSpPr>
         <p:spPr>
           <a:xfrm>
-            <a:off x="640080" y="3593592"/>
-            <a:ext cx="676656" cy="676656"/>
+            <a:off x="640080" y="3666744"/>
+            <a:ext cx="658368" cy="658368"/>
           </a:xfrm>
           <a:prstGeom prst="ellipse">
             <a:avLst/>
@@ -4751,8 +4627,8 @@
         </p:nvSpPr>
         <p:spPr>
           <a:xfrm>
-            <a:off x="640080" y="3593592"/>
-            <a:ext cx="676656" cy="676656"/>
+            <a:off x="640080" y="3666744"/>
+            <a:ext cx="658368" cy="658368"/>
           </a:xfrm>
           <a:prstGeom prst="rect">
             <a:avLst/>
@@ -4790,8 +4666,8 @@
         </p:nvSpPr>
         <p:spPr>
           <a:xfrm>
-            <a:off x="1554480" y="3429000"/>
-            <a:ext cx="4114800" cy="1005840"/>
+            <a:off x="1554480" y="3520440"/>
+            <a:ext cx="4114800" cy="960120"/>
           </a:xfrm>
           <a:prstGeom prst="rect">
             <a:avLst/>
@@ -4829,51 +4705,6 @@
               <a:t>Never put look-alike items in one bin; use the cross method</a:t>
             </a:r>
             <a:endParaRPr lang="en-US" sz="1700" dirty="0"/>
-          </a:p>
-        </p:txBody>
-      </p:sp>
-      <p:sp>
-        <p:nvSpPr>
-          <p:cNvPr id="25" name="Slide Number Placeholder 0"/>
-          <p:cNvSpPr>
-            <a:spLocks noGrp="1"/>
-          </p:cNvSpPr>
-          <p:nvPr>
-            <p:ph type="sldNum" sz="quarter" idx="4294967295"/>
-          </p:nvPr>
-        </p:nvSpPr>
-        <p:spPr>
-          <a:xfrm>
-            <a:off x="8503920" y="4754880"/>
-            <a:ext cx="365760" cy="274320"/>
-          </a:xfrm>
-          <a:prstGeom prst="rect">
-            <a:avLst/>
-          </a:prstGeom>
-          <a:extLst>
-            <a:ext uri="{C572A759-6A51-4108-AA02-DFA0A04FC94B}">
-              <ma14:wrappingTextBoxFlag xmlns:ma14="http://schemas.microsoft.com/office/mac/drawingml/2011/main" val="0"/>
-            </a:ext>
-          </a:extLst>
-        </p:spPr>
-        <p:txBody>
-          <a:bodyPr/>
-          <a:lstStyle>
-            <a:lvl1pPr>
-              <a:defRPr sz="1000">
-                <a:solidFill>
-                  <a:srgbClr val="8A97A5"/>
-                </a:solidFill>
-              </a:defRPr>
-            </a:lvl1pPr>
-          </a:lstStyle>
-          <a:p>
-            <a:pPr algn="l"/>
-            <a:fld id="{F7021451-1387-4CA6-816F-3879F97B5CBC}" type="slidenum">
-              <a:rPr b="0" lang="en-US"/>
-              <a:t>13</a:t>
-            </a:fld>
-            <a:endParaRPr lang="en-US"/>
           </a:p>
         </p:txBody>
       </p:sp>
@@ -4907,13 +4738,13 @@
           <p:cNvPr id="2" name="Text 0"/>
           <p:cNvSpPr/>
           <p:nvPr>
-            <p:ph idx="100" type="title" hasCustomPrompt="1"/>
+            <p:ph idx="101" type="title" hasCustomPrompt="1"/>
           </p:nvPr>
         </p:nvSpPr>
         <p:spPr>
           <a:xfrm>
-            <a:off x="457200" y="320040"/>
-            <a:ext cx="5394960" cy="685800"/>
+            <a:off x="457200" y="640080"/>
+            <a:ext cx="5394960" cy="548640"/>
           </a:xfrm>
           <a:prstGeom prst="rect">
             <a:avLst/>
@@ -4929,14 +4760,14 @@
               <a:buNone/>
             </a:pPr>
             <a:r>
-              <a:rPr lang="en-US" sz="3000" b="1" dirty="0">
+              <a:rPr lang="en-US" sz="2800" b="1" dirty="0">
                 <a:solidFill>
                   <a:schemeClr val="tx1"/>
                 </a:solidFill>
               </a:rPr>
               <a:t>Your shift, bin by bin</a:t>
             </a:r>
-            <a:endParaRPr lang="en-US" sz="3000" dirty="0"/>
+            <a:endParaRPr lang="en-US" sz="2800" dirty="0"/>
           </a:p>
         </p:txBody>
       </p:sp>
@@ -4948,7 +4779,7 @@
         </p:nvSpPr>
         <p:spPr>
           <a:xfrm>
-            <a:off x="868680" y="1280160"/>
+            <a:off x="868680" y="1371600"/>
             <a:ext cx="868680" cy="868680"/>
           </a:xfrm>
           <a:prstGeom prst="ellipse">
@@ -4976,7 +4807,7 @@
         </p:blipFill>
         <p:spPr>
           <a:xfrm>
-            <a:off x="1088136" y="1499616"/>
+            <a:off x="1088136" y="1591056"/>
             <a:ext cx="429768" cy="429768"/>
           </a:xfrm>
           <a:prstGeom prst="rect">
@@ -4992,7 +4823,7 @@
         </p:nvSpPr>
         <p:spPr>
           <a:xfrm>
-            <a:off x="457200" y="2331720"/>
+            <a:off x="457200" y="2423160"/>
             <a:ext cx="1691640" cy="1097280"/>
           </a:xfrm>
           <a:prstGeom prst="rect">
@@ -5050,7 +4881,7 @@
         </p:blipFill>
         <p:spPr>
           <a:xfrm>
-            <a:off x="2121408" y="1572768"/>
+            <a:off x="2121408" y="1664208"/>
             <a:ext cx="274320" cy="274320"/>
           </a:xfrm>
           <a:prstGeom prst="rect">
@@ -5066,7 +4897,7 @@
         </p:nvSpPr>
         <p:spPr>
           <a:xfrm>
-            <a:off x="2697480" y="1280160"/>
+            <a:off x="2697480" y="1371600"/>
             <a:ext cx="868680" cy="868680"/>
           </a:xfrm>
           <a:prstGeom prst="ellipse">
@@ -5094,7 +4925,7 @@
         </p:blipFill>
         <p:spPr>
           <a:xfrm>
-            <a:off x="2916936" y="1499616"/>
+            <a:off x="2916936" y="1591056"/>
             <a:ext cx="429768" cy="429768"/>
           </a:xfrm>
           <a:prstGeom prst="rect">
@@ -5110,7 +4941,7 @@
         </p:nvSpPr>
         <p:spPr>
           <a:xfrm>
-            <a:off x="2286000" y="2331720"/>
+            <a:off x="2286000" y="2423160"/>
             <a:ext cx="1691640" cy="1097280"/>
           </a:xfrm>
           <a:prstGeom prst="rect">
@@ -5168,7 +4999,7 @@
         </p:blipFill>
         <p:spPr>
           <a:xfrm>
-            <a:off x="3950208" y="1572768"/>
+            <a:off x="3950208" y="1664208"/>
             <a:ext cx="274320" cy="274320"/>
           </a:xfrm>
           <a:prstGeom prst="rect">
@@ -5184,7 +5015,7 @@
         </p:nvSpPr>
         <p:spPr>
           <a:xfrm>
-            <a:off x="4526280" y="1280160"/>
+            <a:off x="4526280" y="1371600"/>
             <a:ext cx="868680" cy="868680"/>
           </a:xfrm>
           <a:prstGeom prst="ellipse">
@@ -5212,7 +5043,7 @@
         </p:blipFill>
         <p:spPr>
           <a:xfrm>
-            <a:off x="4745736" y="1499616"/>
+            <a:off x="4745736" y="1591056"/>
             <a:ext cx="429768" cy="429768"/>
           </a:xfrm>
           <a:prstGeom prst="rect">
@@ -5228,7 +5059,7 @@
         </p:nvSpPr>
         <p:spPr>
           <a:xfrm>
-            <a:off x="4114800" y="2331720"/>
+            <a:off x="4114800" y="2423160"/>
             <a:ext cx="1691640" cy="1097280"/>
           </a:xfrm>
           <a:prstGeom prst="rect">
@@ -5278,7 +5109,7 @@
         </p:nvSpPr>
         <p:spPr>
           <a:xfrm>
-            <a:off x="457200" y="3657600"/>
+            <a:off x="457200" y="3749040"/>
             <a:ext cx="5394960" cy="777240"/>
           </a:xfrm>
           <a:prstGeom prst="roundRect">
@@ -5300,7 +5131,7 @@
         </p:nvSpPr>
         <p:spPr>
           <a:xfrm>
-            <a:off x="731520" y="3657600"/>
+            <a:off x="731520" y="3749040"/>
             <a:ext cx="4846320" cy="777240"/>
           </a:xfrm>
           <a:prstGeom prst="rect">
@@ -5319,7 +5150,7 @@
             <a:r>
               <a:rPr lang="en-US" sz="1600" b="1" dirty="0">
                 <a:solidFill>
-                  <a:schemeClr val="accent5"/>
+                  <a:srgbClr val="9EDFF7"/>
                 </a:solidFill>
               </a:rPr>
               <a:t>Goal: </a:t>
@@ -5336,51 +5167,6 @@
               <a:t>fewer units falling, lower wAPMT, happier customers.</a:t>
             </a:r>
             <a:endParaRPr lang="en-US" sz="1600" dirty="0"/>
-          </a:p>
-        </p:txBody>
-      </p:sp>
-      <p:sp>
-        <p:nvSpPr>
-          <p:cNvPr id="25" name="Slide Number Placeholder 0"/>
-          <p:cNvSpPr>
-            <a:spLocks noGrp="1"/>
-          </p:cNvSpPr>
-          <p:nvPr>
-            <p:ph type="sldNum" sz="quarter" idx="4294967295"/>
-          </p:nvPr>
-        </p:nvSpPr>
-        <p:spPr>
-          <a:xfrm>
-            <a:off x="8503920" y="4754880"/>
-            <a:ext cx="365760" cy="274320"/>
-          </a:xfrm>
-          <a:prstGeom prst="rect">
-            <a:avLst/>
-          </a:prstGeom>
-          <a:extLst>
-            <a:ext uri="{C572A759-6A51-4108-AA02-DFA0A04FC94B}">
-              <ma14:wrappingTextBoxFlag xmlns:ma14="http://schemas.microsoft.com/office/mac/drawingml/2011/main" val="0"/>
-            </a:ext>
-          </a:extLst>
-        </p:spPr>
-        <p:txBody>
-          <a:bodyPr/>
-          <a:lstStyle>
-            <a:lvl1pPr>
-              <a:defRPr sz="1000">
-                <a:solidFill>
-                  <a:srgbClr val="8A97A5"/>
-                </a:solidFill>
-              </a:defRPr>
-            </a:lvl1pPr>
-          </a:lstStyle>
-          <a:p>
-            <a:pPr algn="l"/>
-            <a:fld id="{F7021451-1387-4CA6-816F-3879F97B5CBC}" type="slidenum">
-              <a:rPr b="0" lang="en-US"/>
-              <a:t>14</a:t>
-            </a:fld>
-            <a:endParaRPr lang="en-US"/>
           </a:p>
         </p:txBody>
       </p:sp>
@@ -5411,121 +5197,118 @@
       </p:grpSpPr>
       <p:sp>
         <p:nvSpPr>
-          <p:cNvPr id="2" name="Text 0"/>
-          <p:cNvSpPr/>
-          <p:nvPr>
-            <p:ph idx="100" type="body" hasCustomPrompt="1"/>
-          </p:nvPr>
-        </p:nvSpPr>
-        <p:spPr>
-          <a:xfrm>
-            <a:off x="457200" y="1143000"/>
-            <a:ext cx="5394960" cy="365760"/>
-          </a:xfrm>
-          <a:prstGeom prst="rect">
-            <a:avLst/>
-          </a:prstGeom>
-          <a:noFill/>
-          <a:ln/>
-        </p:spPr>
-        <p:txBody>
-          <a:bodyPr wrap="square" lIns="0" tIns="0" rIns="0" bIns="0" rtlCol="0"/>
-          <a:lstStyle/>
-          <a:p>
-            <a:pPr indent="0" marL="0">
-              <a:buNone/>
-            </a:pPr>
-            <a:r>
-              <a:rPr lang="en-US" sz="1400" b="1" spc="300" kern="0" dirty="0">
+          <p:cNvPr id="2" name="Closing title"/>
+          <p:cNvSpPr txBox="1"/>
+          <p:nvPr/>
+        </p:nvSpPr>
+        <p:spPr>
+          <a:xfrm>
+            <a:off x="1371600" y="411480"/>
+            <a:ext cx="6400800" cy="640080"/>
+          </a:xfrm>
+          <a:prstGeom prst="rect">
+            <a:avLst/>
+          </a:prstGeom>
+          <a:noFill/>
+          <a:ln/>
+        </p:spPr>
+        <p:txBody>
+          <a:bodyPr wrap="square" lIns="0" tIns="0" rIns="0" bIns="0" rtlCol="0" anchor="ctr"/>
+          <a:lstStyle/>
+          <a:p>
+            <a:pPr algn="ctr" indent="0" marL="0">
+              <a:buNone/>
+            </a:pPr>
+            <a:r>
+              <a:rPr lang="en-US" sz="3200" dirty="0">
                 <a:solidFill>
                   <a:schemeClr val="accent1"/>
                 </a:solidFill>
-              </a:rPr>
-              <a:t>THANK YOU</a:t>
-            </a:r>
-            <a:endParaRPr lang="en-US" sz="1400" dirty="0"/>
-          </a:p>
-        </p:txBody>
-      </p:sp>
-      <p:sp>
-        <p:nvSpPr>
-          <p:cNvPr id="3" name="Text 0"/>
-          <p:cNvSpPr/>
-          <p:nvPr>
-            <p:ph idx="101" type="title" hasCustomPrompt="1"/>
-          </p:nvPr>
-        </p:nvSpPr>
-        <p:spPr>
-          <a:xfrm>
-            <a:off x="457200" y="1554480"/>
-            <a:ext cx="5394960" cy="1463040"/>
-          </a:xfrm>
-          <a:prstGeom prst="rect">
-            <a:avLst/>
-          </a:prstGeom>
-          <a:noFill/>
-          <a:ln/>
-        </p:spPr>
-        <p:txBody>
-          <a:bodyPr wrap="square" lIns="0" tIns="0" rIns="0" bIns="0" rtlCol="0" anchor="t"/>
-          <a:lstStyle/>
-          <a:p>
-            <a:pPr algn="l" indent="0" marL="0">
-              <a:buNone/>
-            </a:pPr>
-            <a:r>
-              <a:rPr lang="en-US" sz="4000" b="1" dirty="0">
-                <a:solidFill>
-                  <a:schemeClr val="bg1"/>
+                <a:latin typeface="Arial" pitchFamily="34" charset="0"/>
+                <a:ea typeface="Arial" pitchFamily="34" charset="-122"/>
+                <a:cs typeface="Arial" pitchFamily="34" charset="-120"/>
+              </a:rPr>
+              <a:t>Learn and be curious</a:t>
+            </a:r>
+            <a:endParaRPr lang="en-US" sz="3200" dirty="0"/>
+          </a:p>
+        </p:txBody>
+      </p:sp>
+      <p:sp>
+        <p:nvSpPr>
+          <p:cNvPr id="3" name="Closing tagline"/>
+          <p:cNvSpPr txBox="1"/>
+          <p:nvPr/>
+        </p:nvSpPr>
+        <p:spPr>
+          <a:xfrm>
+            <a:off x="1371600" y="2651760"/>
+            <a:ext cx="6400800" cy="457200"/>
+          </a:xfrm>
+          <a:prstGeom prst="rect">
+            <a:avLst/>
+          </a:prstGeom>
+          <a:noFill/>
+          <a:ln/>
+        </p:spPr>
+        <p:txBody>
+          <a:bodyPr wrap="square" lIns="0" tIns="0" rIns="0" bIns="0" rtlCol="0" anchor="ctr"/>
+          <a:lstStyle/>
+          <a:p>
+            <a:pPr algn="ctr" indent="0" marL="0">
+              <a:buNone/>
+            </a:pPr>
+            <a:r>
+              <a:rPr lang="en-US" sz="1800" b="1" dirty="0">
+                <a:solidFill>
+                  <a:schemeClr val="tx1"/>
                 </a:solidFill>
               </a:rPr>
               <a:t>Small fixes. Big impact.</a:t>
             </a:r>
-            <a:endParaRPr lang="en-US" sz="4000" dirty="0"/>
-          </a:p>
-        </p:txBody>
-      </p:sp>
-      <p:sp>
-        <p:nvSpPr>
-          <p:cNvPr id="4" name="Text 0"/>
-          <p:cNvSpPr/>
-          <p:nvPr>
-            <p:ph idx="102" type="body" hasCustomPrompt="1"/>
-          </p:nvPr>
-        </p:nvSpPr>
-        <p:spPr>
-          <a:xfrm>
-            <a:off x="457200" y="3063240"/>
-            <a:ext cx="4846320" cy="822960"/>
-          </a:xfrm>
-          <a:prstGeom prst="rect">
-            <a:avLst/>
-          </a:prstGeom>
-          <a:noFill/>
-          <a:ln/>
-        </p:spPr>
-        <p:txBody>
-          <a:bodyPr wrap="square" lIns="0" tIns="0" rIns="0" bIns="0" rtlCol="0" anchor="t"/>
-          <a:lstStyle/>
-          <a:p>
-            <a:pPr indent="0" marL="0">
-              <a:buNone/>
-            </a:pPr>
-            <a:r>
-              <a:rPr lang="en-US" sz="1800" dirty="0">
-                <a:solidFill>
-                  <a:srgbClr val="C9D3DD"/>
-                </a:solidFill>
-              </a:rPr>
-              <a:t>Questions? Ask your Process Guide, Area Manager or ICQA team.</a:t>
-            </a:r>
             <a:endParaRPr lang="en-US" sz="1800" dirty="0"/>
+          </a:p>
+        </p:txBody>
+      </p:sp>
+      <p:sp>
+        <p:nvSpPr>
+          <p:cNvPr id="4" name="Rate label"/>
+          <p:cNvSpPr txBox="1"/>
+          <p:nvPr/>
+        </p:nvSpPr>
+        <p:spPr>
+          <a:xfrm>
+            <a:off x="2788920" y="3429000"/>
+            <a:ext cx="1600200" cy="365760"/>
+          </a:xfrm>
+          <a:prstGeom prst="rect">
+            <a:avLst/>
+          </a:prstGeom>
+          <a:noFill/>
+          <a:ln/>
+        </p:spPr>
+        <p:txBody>
+          <a:bodyPr wrap="square" lIns="0" tIns="0" rIns="0" bIns="0" rtlCol="0" anchor="ctr"/>
+          <a:lstStyle/>
+          <a:p>
+            <a:pPr algn="r" indent="0" marL="0">
+              <a:buNone/>
+            </a:pPr>
+            <a:r>
+              <a:rPr lang="en-US" sz="1600" dirty="0">
+                <a:solidFill>
+                  <a:schemeClr val="tx1"/>
+                </a:solidFill>
+              </a:rPr>
+              <a:t>Rate this video</a:t>
+            </a:r>
+            <a:endParaRPr lang="en-US" sz="1600" dirty="0"/>
           </a:p>
         </p:txBody>
       </p:sp>
       <p:pic>
         <p:nvPicPr>
-          <p:cNvPr id="5" name="Close icon" descr="preencoded.png">    </p:cNvPr>
+          <p:cNvPr id="5" name="Star 1" descr="preencoded.png">    </p:cNvPr>
           <p:cNvPicPr>
             <a:picLocks noChangeAspect="1"/>
           </p:cNvPicPr>
@@ -5539,8 +5322,104 @@
         </p:blipFill>
         <p:spPr>
           <a:xfrm>
-            <a:off x="457200" y="457200"/>
-            <a:ext cx="502920" cy="502920"/>
+            <a:off x="4526280" y="3474720"/>
+            <a:ext cx="274320" cy="274320"/>
+          </a:xfrm>
+          <a:prstGeom prst="rect">
+            <a:avLst/>
+          </a:prstGeom>
+        </p:spPr>
+      </p:pic>
+      <p:pic>
+        <p:nvPicPr>
+          <p:cNvPr id="6" name="Star 2" descr="preencoded.png">    </p:cNvPr>
+          <p:cNvPicPr>
+            <a:picLocks noChangeAspect="1"/>
+          </p:cNvPicPr>
+          <p:nvPr/>
+        </p:nvPicPr>
+        <p:blipFill>
+          <a:blip r:embed="rId2"/>
+          <a:stretch>
+            <a:fillRect/>
+          </a:stretch>
+        </p:blipFill>
+        <p:spPr>
+          <a:xfrm>
+            <a:off x="4873752" y="3474720"/>
+            <a:ext cx="274320" cy="274320"/>
+          </a:xfrm>
+          <a:prstGeom prst="rect">
+            <a:avLst/>
+          </a:prstGeom>
+        </p:spPr>
+      </p:pic>
+      <p:pic>
+        <p:nvPicPr>
+          <p:cNvPr id="7" name="Star 3" descr="preencoded.png">    </p:cNvPr>
+          <p:cNvPicPr>
+            <a:picLocks noChangeAspect="1"/>
+          </p:cNvPicPr>
+          <p:nvPr/>
+        </p:nvPicPr>
+        <p:blipFill>
+          <a:blip r:embed="rId3"/>
+          <a:stretch>
+            <a:fillRect/>
+          </a:stretch>
+        </p:blipFill>
+        <p:spPr>
+          <a:xfrm>
+            <a:off x="5221224" y="3474720"/>
+            <a:ext cx="274320" cy="274320"/>
+          </a:xfrm>
+          <a:prstGeom prst="rect">
+            <a:avLst/>
+          </a:prstGeom>
+        </p:spPr>
+      </p:pic>
+      <p:pic>
+        <p:nvPicPr>
+          <p:cNvPr id="8" name="Star 4" descr="preencoded.png">    </p:cNvPr>
+          <p:cNvPicPr>
+            <a:picLocks noChangeAspect="1"/>
+          </p:cNvPicPr>
+          <p:nvPr/>
+        </p:nvPicPr>
+        <p:blipFill>
+          <a:blip r:embed="rId4"/>
+          <a:stretch>
+            <a:fillRect/>
+          </a:stretch>
+        </p:blipFill>
+        <p:spPr>
+          <a:xfrm>
+            <a:off x="5568696" y="3474720"/>
+            <a:ext cx="274320" cy="274320"/>
+          </a:xfrm>
+          <a:prstGeom prst="rect">
+            <a:avLst/>
+          </a:prstGeom>
+        </p:spPr>
+      </p:pic>
+      <p:pic>
+        <p:nvPicPr>
+          <p:cNvPr id="9" name="Star 5" descr="preencoded.png">    </p:cNvPr>
+          <p:cNvPicPr>
+            <a:picLocks noChangeAspect="1"/>
+          </p:cNvPicPr>
+          <p:nvPr/>
+        </p:nvPicPr>
+        <p:blipFill>
+          <a:blip r:embed="rId5"/>
+          <a:stretch>
+            <a:fillRect/>
+          </a:stretch>
+        </p:blipFill>
+        <p:spPr>
+          <a:xfrm>
+            <a:off x="5916168" y="3474720"/>
+            <a:ext cx="274320" cy="274320"/>
           </a:xfrm>
           <a:prstGeom prst="rect">
             <a:avLst/>
@@ -5577,13 +5456,13 @@
           <p:cNvPr id="2" name="Text 0"/>
           <p:cNvSpPr/>
           <p:nvPr>
-            <p:ph idx="100" type="title" hasCustomPrompt="1"/>
+            <p:ph idx="101" type="title" hasCustomPrompt="1"/>
           </p:nvPr>
         </p:nvSpPr>
         <p:spPr>
           <a:xfrm>
-            <a:off x="457200" y="320040"/>
-            <a:ext cx="5394960" cy="685800"/>
+            <a:off x="457200" y="640080"/>
+            <a:ext cx="5394960" cy="548640"/>
           </a:xfrm>
           <a:prstGeom prst="rect">
             <a:avLst/>
@@ -5599,14 +5478,14 @@
               <a:buNone/>
             </a:pPr>
             <a:r>
-              <a:rPr lang="en-US" sz="3000" b="1" dirty="0">
+              <a:rPr lang="en-US" sz="2800" b="1" dirty="0">
                 <a:solidFill>
                   <a:schemeClr val="tx1"/>
                 </a:solidFill>
               </a:rPr>
               <a:t>What is amnesty?</a:t>
             </a:r>
-            <a:endParaRPr lang="en-US" sz="3000" dirty="0"/>
+            <a:endParaRPr lang="en-US" sz="2800" dirty="0"/>
           </a:p>
         </p:txBody>
       </p:sp>
@@ -5618,7 +5497,7 @@
         </p:nvSpPr>
         <p:spPr>
           <a:xfrm>
-            <a:off x="457200" y="1097280"/>
+            <a:off x="457200" y="1280160"/>
             <a:ext cx="5394960" cy="548640"/>
           </a:xfrm>
           <a:prstGeom prst="rect">
@@ -5637,7 +5516,7 @@
             <a:r>
               <a:rPr lang="en-US" sz="1800" i="1" dirty="0">
                 <a:solidFill>
-                  <a:schemeClr val="accent1"/>
+                  <a:schemeClr val="accent6"/>
                 </a:solidFill>
               </a:rPr>
               <a:t>Any product that is physically not in its assigned virtual location.</a:t>
@@ -5654,14 +5533,14 @@
         </p:nvSpPr>
         <p:spPr>
           <a:xfrm>
-            <a:off x="457200" y="1874520"/>
+            <a:off x="457200" y="2011680"/>
             <a:ext cx="640080" cy="640080"/>
           </a:xfrm>
           <a:prstGeom prst="ellipse">
             <a:avLst/>
           </a:prstGeom>
           <a:solidFill>
-            <a:schemeClr val="bg2"/>
+            <a:schemeClr val="bg1"/>
           </a:solidFill>
           <a:ln/>
         </p:spPr>
@@ -5682,7 +5561,7 @@
         </p:blipFill>
         <p:spPr>
           <a:xfrm>
-            <a:off x="621792" y="2039112"/>
+            <a:off x="621792" y="2176272"/>
             <a:ext cx="310896" cy="310896"/>
           </a:xfrm>
           <a:prstGeom prst="rect">
@@ -5698,7 +5577,7 @@
         </p:nvSpPr>
         <p:spPr>
           <a:xfrm>
-            <a:off x="1325880" y="1856232"/>
+            <a:off x="1325880" y="1993392"/>
             <a:ext cx="4526280" cy="685800"/>
           </a:xfrm>
           <a:prstGeom prst="rect">
@@ -5748,14 +5627,14 @@
         </p:nvSpPr>
         <p:spPr>
           <a:xfrm>
-            <a:off x="457200" y="2834640"/>
+            <a:off x="457200" y="2926080"/>
             <a:ext cx="640080" cy="640080"/>
           </a:xfrm>
           <a:prstGeom prst="ellipse">
             <a:avLst/>
           </a:prstGeom>
           <a:solidFill>
-            <a:schemeClr val="bg2"/>
+            <a:schemeClr val="bg1"/>
           </a:solidFill>
           <a:ln/>
         </p:spPr>
@@ -5776,7 +5655,7 @@
         </p:blipFill>
         <p:spPr>
           <a:xfrm>
-            <a:off x="621792" y="2999232"/>
+            <a:off x="621792" y="3090672"/>
             <a:ext cx="310896" cy="310896"/>
           </a:xfrm>
           <a:prstGeom prst="rect">
@@ -5792,7 +5671,7 @@
         </p:nvSpPr>
         <p:spPr>
           <a:xfrm>
-            <a:off x="1325880" y="2816352"/>
+            <a:off x="1325880" y="2907792"/>
             <a:ext cx="4526280" cy="685800"/>
           </a:xfrm>
           <a:prstGeom prst="rect">
@@ -5842,14 +5721,14 @@
         </p:nvSpPr>
         <p:spPr>
           <a:xfrm>
-            <a:off x="457200" y="3794760"/>
+            <a:off x="457200" y="3840480"/>
             <a:ext cx="640080" cy="640080"/>
           </a:xfrm>
           <a:prstGeom prst="ellipse">
             <a:avLst/>
           </a:prstGeom>
           <a:solidFill>
-            <a:schemeClr val="bg2"/>
+            <a:schemeClr val="bg1"/>
           </a:solidFill>
           <a:ln/>
         </p:spPr>
@@ -5870,7 +5749,7 @@
         </p:blipFill>
         <p:spPr>
           <a:xfrm>
-            <a:off x="621792" y="3959352"/>
+            <a:off x="621792" y="4005072"/>
             <a:ext cx="310896" cy="310896"/>
           </a:xfrm>
           <a:prstGeom prst="rect">
@@ -5886,7 +5765,7 @@
         </p:nvSpPr>
         <p:spPr>
           <a:xfrm>
-            <a:off x="1325880" y="3776472"/>
+            <a:off x="1325880" y="3822192"/>
             <a:ext cx="4526280" cy="685800"/>
           </a:xfrm>
           <a:prstGeom prst="rect">
@@ -5925,51 +5804,6 @@
               <a:t>It can cause a true pick short and a re-pick</a:t>
             </a:r>
             <a:endParaRPr lang="en-US" sz="1700" dirty="0"/>
-          </a:p>
-        </p:txBody>
-      </p:sp>
-      <p:sp>
-        <p:nvSpPr>
-          <p:cNvPr id="25" name="Slide Number Placeholder 0"/>
-          <p:cNvSpPr>
-            <a:spLocks noGrp="1"/>
-          </p:cNvSpPr>
-          <p:nvPr>
-            <p:ph type="sldNum" sz="quarter" idx="4294967295"/>
-          </p:nvPr>
-        </p:nvSpPr>
-        <p:spPr>
-          <a:xfrm>
-            <a:off x="8503920" y="4754880"/>
-            <a:ext cx="365760" cy="274320"/>
-          </a:xfrm>
-          <a:prstGeom prst="rect">
-            <a:avLst/>
-          </a:prstGeom>
-          <a:extLst>
-            <a:ext uri="{C572A759-6A51-4108-AA02-DFA0A04FC94B}">
-              <ma14:wrappingTextBoxFlag xmlns:ma14="http://schemas.microsoft.com/office/mac/drawingml/2011/main" val="0"/>
-            </a:ext>
-          </a:extLst>
-        </p:spPr>
-        <p:txBody>
-          <a:bodyPr/>
-          <a:lstStyle>
-            <a:lvl1pPr>
-              <a:defRPr sz="1000">
-                <a:solidFill>
-                  <a:srgbClr val="8A97A5"/>
-                </a:solidFill>
-              </a:defRPr>
-            </a:lvl1pPr>
-          </a:lstStyle>
-          <a:p>
-            <a:pPr algn="l"/>
-            <a:fld id="{F7021451-1387-4CA6-816F-3879F97B5CBC}" type="slidenum">
-              <a:rPr b="0" lang="en-US"/>
-              <a:t>2</a:t>
-            </a:fld>
-            <a:endParaRPr lang="en-US"/>
           </a:p>
         </p:txBody>
       </p:sp>
@@ -6003,13 +5837,13 @@
           <p:cNvPr id="2" name="Text 0"/>
           <p:cNvSpPr/>
           <p:nvPr>
-            <p:ph idx="100" type="title" hasCustomPrompt="1"/>
+            <p:ph idx="101" type="title" hasCustomPrompt="1"/>
           </p:nvPr>
         </p:nvSpPr>
         <p:spPr>
           <a:xfrm>
-            <a:off x="457200" y="320040"/>
-            <a:ext cx="5394960" cy="685800"/>
+            <a:off x="457200" y="640080"/>
+            <a:ext cx="5394960" cy="548640"/>
           </a:xfrm>
           <a:prstGeom prst="rect">
             <a:avLst/>
@@ -6025,14 +5859,14 @@
               <a:buNone/>
             </a:pPr>
             <a:r>
-              <a:rPr lang="en-US" sz="3000" b="1" dirty="0">
+              <a:rPr lang="en-US" sz="2800" b="1" dirty="0">
                 <a:solidFill>
                   <a:schemeClr val="tx1"/>
                 </a:solidFill>
               </a:rPr>
               <a:t>Where amnesty comes from</a:t>
             </a:r>
-            <a:endParaRPr lang="en-US" sz="3000" dirty="0"/>
+            <a:endParaRPr lang="en-US" sz="2800" dirty="0"/>
           </a:p>
         </p:txBody>
       </p:sp>
@@ -6044,16 +5878,16 @@
         </p:nvSpPr>
         <p:spPr>
           <a:xfrm>
-            <a:off x="457200" y="1143000"/>
-            <a:ext cx="2606040" cy="1920240"/>
+            <a:off x="457200" y="1325880"/>
+            <a:ext cx="2606040" cy="1783080"/>
           </a:xfrm>
           <a:prstGeom prst="roundRect">
             <a:avLst>
-              <a:gd name="adj" fmla="val 4762"/>
+              <a:gd name="adj" fmla="val 5128"/>
             </a:avLst>
           </a:prstGeom>
           <a:solidFill>
-            <a:schemeClr val="bg2"/>
+            <a:schemeClr val="bg1"/>
           </a:solidFill>
           <a:ln/>
         </p:spPr>
@@ -6074,7 +5908,7 @@
         </p:blipFill>
         <p:spPr>
           <a:xfrm>
-            <a:off x="685800" y="1325880"/>
+            <a:off x="685800" y="1508760"/>
             <a:ext cx="411480" cy="411480"/>
           </a:xfrm>
           <a:prstGeom prst="rect">
@@ -6090,8 +5924,8 @@
         </p:nvSpPr>
         <p:spPr>
           <a:xfrm>
-            <a:off x="685800" y="1828800"/>
-            <a:ext cx="2194560" cy="1143000"/>
+            <a:off x="685800" y="2011680"/>
+            <a:ext cx="2194560" cy="1005840"/>
           </a:xfrm>
           <a:prstGeom prst="rect">
             <a:avLst/>
@@ -6140,16 +5974,16 @@
         </p:nvSpPr>
         <p:spPr>
           <a:xfrm>
-            <a:off x="3246120" y="1143000"/>
-            <a:ext cx="2606040" cy="1920240"/>
+            <a:off x="3246120" y="1325880"/>
+            <a:ext cx="2606040" cy="1783080"/>
           </a:xfrm>
           <a:prstGeom prst="roundRect">
             <a:avLst>
-              <a:gd name="adj" fmla="val 4762"/>
+              <a:gd name="adj" fmla="val 5128"/>
             </a:avLst>
           </a:prstGeom>
           <a:solidFill>
-            <a:schemeClr val="bg2"/>
+            <a:schemeClr val="bg1"/>
           </a:solidFill>
           <a:ln/>
         </p:spPr>
@@ -6170,7 +6004,7 @@
         </p:blipFill>
         <p:spPr>
           <a:xfrm>
-            <a:off x="3474720" y="1325880"/>
+            <a:off x="3474720" y="1508760"/>
             <a:ext cx="411480" cy="411480"/>
           </a:xfrm>
           <a:prstGeom prst="rect">
@@ -6186,8 +6020,8 @@
         </p:nvSpPr>
         <p:spPr>
           <a:xfrm>
-            <a:off x="3474720" y="1828800"/>
-            <a:ext cx="2194560" cy="1143000"/>
+            <a:off x="3474720" y="2011680"/>
+            <a:ext cx="2194560" cy="1005840"/>
           </a:xfrm>
           <a:prstGeom prst="rect">
             <a:avLst/>
@@ -6236,12 +6070,12 @@
         </p:nvSpPr>
         <p:spPr>
           <a:xfrm>
-            <a:off x="457200" y="3291840"/>
-            <a:ext cx="5394960" cy="1188720"/>
+            <a:off x="457200" y="3383280"/>
+            <a:ext cx="5394960" cy="1143000"/>
           </a:xfrm>
           <a:prstGeom prst="roundRect">
             <a:avLst>
-              <a:gd name="adj" fmla="val 7692"/>
+              <a:gd name="adj" fmla="val 8000"/>
             </a:avLst>
           </a:prstGeom>
           <a:solidFill>
@@ -6258,8 +6092,8 @@
         </p:nvSpPr>
         <p:spPr>
           <a:xfrm>
-            <a:off x="731520" y="3291840"/>
-            <a:ext cx="4846320" cy="1188720"/>
+            <a:off x="731520" y="3383280"/>
+            <a:ext cx="4846320" cy="1143000"/>
           </a:xfrm>
           <a:prstGeom prst="rect">
             <a:avLst/>
@@ -6291,57 +6125,12 @@
             <a:r>
               <a:rPr lang="en-US" sz="1500" dirty="0">
                 <a:solidFill>
-                  <a:schemeClr val="accent5"/>
+                  <a:srgbClr val="9EDFF7"/>
                 </a:solidFill>
               </a:rPr>
               <a:t>Good bin etiquette is something every one of us controls.</a:t>
             </a:r>
             <a:endParaRPr lang="en-US" sz="1800" dirty="0"/>
-          </a:p>
-        </p:txBody>
-      </p:sp>
-      <p:sp>
-        <p:nvSpPr>
-          <p:cNvPr id="25" name="Slide Number Placeholder 0"/>
-          <p:cNvSpPr>
-            <a:spLocks noGrp="1"/>
-          </p:cNvSpPr>
-          <p:nvPr>
-            <p:ph type="sldNum" sz="quarter" idx="4294967295"/>
-          </p:nvPr>
-        </p:nvSpPr>
-        <p:spPr>
-          <a:xfrm>
-            <a:off x="8503920" y="4754880"/>
-            <a:ext cx="365760" cy="274320"/>
-          </a:xfrm>
-          <a:prstGeom prst="rect">
-            <a:avLst/>
-          </a:prstGeom>
-          <a:extLst>
-            <a:ext uri="{C572A759-6A51-4108-AA02-DFA0A04FC94B}">
-              <ma14:wrappingTextBoxFlag xmlns:ma14="http://schemas.microsoft.com/office/mac/drawingml/2011/main" val="0"/>
-            </a:ext>
-          </a:extLst>
-        </p:spPr>
-        <p:txBody>
-          <a:bodyPr/>
-          <a:lstStyle>
-            <a:lvl1pPr>
-              <a:defRPr sz="1000">
-                <a:solidFill>
-                  <a:srgbClr val="8A97A5"/>
-                </a:solidFill>
-              </a:defRPr>
-            </a:lvl1pPr>
-          </a:lstStyle>
-          <a:p>
-            <a:pPr algn="l"/>
-            <a:fld id="{F7021451-1387-4CA6-816F-3879F97B5CBC}" type="slidenum">
-              <a:rPr b="0" lang="en-US"/>
-              <a:t>3</a:t>
-            </a:fld>
-            <a:endParaRPr lang="en-US"/>
           </a:p>
         </p:txBody>
       </p:sp>
@@ -6372,83 +6161,7 @@
       </p:grpSpPr>
       <p:sp>
         <p:nvSpPr>
-          <p:cNvPr id="2" name="Text 0"/>
-          <p:cNvSpPr/>
-          <p:nvPr>
-            <p:ph idx="100" type="body" hasCustomPrompt="1"/>
-          </p:nvPr>
-        </p:nvSpPr>
-        <p:spPr>
-          <a:xfrm>
-            <a:off x="457200" y="1143000"/>
-            <a:ext cx="5394960" cy="365760"/>
-          </a:xfrm>
-          <a:prstGeom prst="rect">
-            <a:avLst/>
-          </a:prstGeom>
-          <a:noFill/>
-          <a:ln/>
-        </p:spPr>
-        <p:txBody>
-          <a:bodyPr wrap="square" lIns="0" tIns="0" rIns="0" bIns="0" rtlCol="0"/>
-          <a:lstStyle/>
-          <a:p>
-            <a:pPr indent="0" marL="0">
-              <a:buNone/>
-            </a:pPr>
-            <a:r>
-              <a:rPr lang="en-US" sz="1400" b="1" spc="300" kern="0" dirty="0">
-                <a:solidFill>
-                  <a:schemeClr val="accent1"/>
-                </a:solidFill>
-              </a:rPr>
-              <a:t>PART 1</a:t>
-            </a:r>
-            <a:endParaRPr lang="en-US" sz="1400" dirty="0"/>
-          </a:p>
-        </p:txBody>
-      </p:sp>
-      <p:sp>
-        <p:nvSpPr>
-          <p:cNvPr id="3" name="Text 0"/>
-          <p:cNvSpPr/>
-          <p:nvPr>
-            <p:ph idx="101" type="title" hasCustomPrompt="1"/>
-          </p:nvPr>
-        </p:nvSpPr>
-        <p:spPr>
-          <a:xfrm>
-            <a:off x="457200" y="1554480"/>
-            <a:ext cx="5394960" cy="1463040"/>
-          </a:xfrm>
-          <a:prstGeom prst="rect">
-            <a:avLst/>
-          </a:prstGeom>
-          <a:noFill/>
-          <a:ln/>
-        </p:spPr>
-        <p:txBody>
-          <a:bodyPr wrap="square" lIns="0" tIns="0" rIns="0" bIns="0" rtlCol="0" anchor="t"/>
-          <a:lstStyle/>
-          <a:p>
-            <a:pPr algn="l" indent="0" marL="0">
-              <a:buNone/>
-            </a:pPr>
-            <a:r>
-              <a:rPr lang="en-US" sz="4000" b="1" dirty="0">
-                <a:solidFill>
-                  <a:schemeClr val="bg1"/>
-                </a:solidFill>
-              </a:rPr>
-              <a:t>First Face Fix</a:t>
-            </a:r>
-            <a:endParaRPr lang="en-US" sz="4000" dirty="0"/>
-          </a:p>
-        </p:txBody>
-      </p:sp>
-      <p:sp>
-        <p:nvSpPr>
-          <p:cNvPr id="4" name="Text 0"/>
+          <p:cNvPr id="2" name="Text 1"/>
           <p:cNvSpPr/>
           <p:nvPr>
             <p:ph idx="102" type="body" hasCustomPrompt="1"/>
@@ -6456,8 +6169,84 @@
         </p:nvSpPr>
         <p:spPr>
           <a:xfrm>
-            <a:off x="457200" y="3063240"/>
-            <a:ext cx="4846320" cy="822960"/>
+            <a:off x="2514600" y="502920"/>
+            <a:ext cx="6400800" cy="320040"/>
+          </a:xfrm>
+          <a:prstGeom prst="rect">
+            <a:avLst/>
+          </a:prstGeom>
+          <a:noFill/>
+          <a:ln/>
+        </p:spPr>
+        <p:txBody>
+          <a:bodyPr wrap="square" lIns="0" tIns="0" rIns="0" bIns="0" rtlCol="0"/>
+          <a:lstStyle/>
+          <a:p>
+            <a:pPr algn="ctr" indent="0" marL="0">
+              <a:buNone/>
+            </a:pPr>
+            <a:r>
+              <a:rPr lang="en-US" sz="1300" b="1" spc="300" kern="0" dirty="0">
+                <a:solidFill>
+                  <a:schemeClr val="accent6"/>
+                </a:solidFill>
+              </a:rPr>
+              <a:t>PART 1</a:t>
+            </a:r>
+            <a:endParaRPr lang="en-US" sz="1300" dirty="0"/>
+          </a:p>
+        </p:txBody>
+      </p:sp>
+      <p:sp>
+        <p:nvSpPr>
+          <p:cNvPr id="3" name="Text 1"/>
+          <p:cNvSpPr/>
+          <p:nvPr>
+            <p:ph idx="103" type="title" hasCustomPrompt="1"/>
+          </p:nvPr>
+        </p:nvSpPr>
+        <p:spPr>
+          <a:xfrm>
+            <a:off x="2514600" y="868680"/>
+            <a:ext cx="6400800" cy="868680"/>
+          </a:xfrm>
+          <a:prstGeom prst="rect">
+            <a:avLst/>
+          </a:prstGeom>
+          <a:noFill/>
+          <a:ln/>
+        </p:spPr>
+        <p:txBody>
+          <a:bodyPr wrap="square" lIns="0" tIns="0" rIns="0" bIns="0" rtlCol="0" anchor="ctr"/>
+          <a:lstStyle/>
+          <a:p>
+            <a:pPr algn="ctr" indent="0" marL="0">
+              <a:buNone/>
+            </a:pPr>
+            <a:r>
+              <a:rPr lang="en-US" sz="3600" b="1" dirty="0">
+                <a:solidFill>
+                  <a:schemeClr val="tx1"/>
+                </a:solidFill>
+              </a:rPr>
+              <a:t>First Face Fix</a:t>
+            </a:r>
+            <a:endParaRPr lang="en-US" sz="3600" dirty="0"/>
+          </a:p>
+        </p:txBody>
+      </p:sp>
+      <p:sp>
+        <p:nvSpPr>
+          <p:cNvPr id="4" name="Text 1"/>
+          <p:cNvSpPr/>
+          <p:nvPr>
+            <p:ph idx="104" type="body" hasCustomPrompt="1"/>
+          </p:nvPr>
+        </p:nvSpPr>
+        <p:spPr>
+          <a:xfrm>
+            <a:off x="2971800" y="1783080"/>
+            <a:ext cx="5486400" cy="685800"/>
           </a:xfrm>
           <a:prstGeom prst="rect">
             <a:avLst/>
@@ -6469,45 +6258,21 @@
           <a:bodyPr wrap="square" lIns="0" tIns="0" rIns="0" bIns="0" rtlCol="0" anchor="t"/>
           <a:lstStyle/>
           <a:p>
-            <a:pPr indent="0" marL="0">
-              <a:buNone/>
-            </a:pPr>
-            <a:r>
-              <a:rPr lang="en-US" sz="1800" dirty="0">
-                <a:solidFill>
-                  <a:srgbClr val="C9D3DD"/>
+            <a:pPr algn="ctr" indent="0" marL="0">
+              <a:buNone/>
+            </a:pPr>
+            <a:r>
+              <a:rPr lang="en-US" sz="1600" dirty="0">
+                <a:solidFill>
+                  <a:schemeClr val="accent4"/>
                 </a:solidFill>
               </a:rPr>
               <a:t>One minute. The first pod face. Every shift start and after every break.</a:t>
             </a:r>
-            <a:endParaRPr lang="en-US" sz="1800" dirty="0"/>
-          </a:p>
-        </p:txBody>
-      </p:sp>
-      <p:pic>
-        <p:nvPicPr>
-          <p:cNvPr id="5" name="Section icon" descr="preencoded.png">    </p:cNvPr>
-          <p:cNvPicPr>
-            <a:picLocks noChangeAspect="1"/>
-          </p:cNvPicPr>
-          <p:nvPr/>
-        </p:nvPicPr>
-        <p:blipFill>
-          <a:blip r:embed="rId1"/>
-          <a:stretch>
-            <a:fillRect/>
-          </a:stretch>
-        </p:blipFill>
-        <p:spPr>
-          <a:xfrm>
-            <a:off x="457200" y="457200"/>
-            <a:ext cx="502920" cy="502920"/>
-          </a:xfrm>
-          <a:prstGeom prst="rect">
-            <a:avLst/>
-          </a:prstGeom>
-        </p:spPr>
-      </p:pic>
+            <a:endParaRPr lang="en-US" sz="1600" dirty="0"/>
+          </a:p>
+        </p:txBody>
+      </p:sp>
     </p:spTree>
   </p:cSld>
   <p:clrMapOvr>
@@ -6538,13 +6303,13 @@
           <p:cNvPr id="2" name="Text 0"/>
           <p:cNvSpPr/>
           <p:nvPr>
-            <p:ph idx="100" type="title" hasCustomPrompt="1"/>
+            <p:ph idx="101" type="title" hasCustomPrompt="1"/>
           </p:nvPr>
         </p:nvSpPr>
         <p:spPr>
           <a:xfrm>
-            <a:off x="457200" y="320040"/>
-            <a:ext cx="5394960" cy="685800"/>
+            <a:off x="457200" y="640080"/>
+            <a:ext cx="5394960" cy="548640"/>
           </a:xfrm>
           <a:prstGeom prst="rect">
             <a:avLst/>
@@ -6560,14 +6325,14 @@
               <a:buNone/>
             </a:pPr>
             <a:r>
-              <a:rPr lang="en-US" sz="3000" b="1" dirty="0">
+              <a:rPr lang="en-US" sz="2800" b="1" dirty="0">
                 <a:solidFill>
                   <a:schemeClr val="tx1"/>
                 </a:solidFill>
               </a:rPr>
               <a:t>What is First Face Fix?</a:t>
             </a:r>
-            <a:endParaRPr lang="en-US" sz="3000" dirty="0"/>
+            <a:endParaRPr lang="en-US" sz="2800" dirty="0"/>
           </a:p>
         </p:txBody>
       </p:sp>
@@ -6579,8 +6344,8 @@
         </p:nvSpPr>
         <p:spPr>
           <a:xfrm>
-            <a:off x="457200" y="1143000"/>
-            <a:ext cx="2011680" cy="3337560"/>
+            <a:off x="457200" y="1325880"/>
+            <a:ext cx="2011680" cy="3200400"/>
           </a:xfrm>
           <a:prstGeom prst="roundRect">
             <a:avLst>
@@ -6588,7 +6353,7 @@
             </a:avLst>
           </a:prstGeom>
           <a:solidFill>
-            <a:schemeClr val="accent1"/>
+            <a:schemeClr val="tx2"/>
           </a:solidFill>
           <a:ln/>
         </p:spPr>
@@ -6601,8 +6366,8 @@
         </p:nvSpPr>
         <p:spPr>
           <a:xfrm>
-            <a:off x="685800" y="1143000"/>
-            <a:ext cx="1554480" cy="3337560"/>
+            <a:off x="685800" y="1325880"/>
+            <a:ext cx="1554480" cy="3200400"/>
           </a:xfrm>
           <a:prstGeom prst="rect">
             <a:avLst/>
@@ -6620,7 +6385,7 @@
             <a:r>
               <a:rPr lang="en-US" sz="7200" b="1" dirty="0">
                 <a:solidFill>
-                  <a:schemeClr val="bg1"/>
+                  <a:schemeClr val="accent1"/>
                 </a:solidFill>
               </a:rPr>
               <a:t>1</a:t>
@@ -6659,7 +6424,7 @@
         </p:blipFill>
         <p:spPr>
           <a:xfrm>
-            <a:off x="2743200" y="1261872"/>
+            <a:off x="2743200" y="1444752"/>
             <a:ext cx="347472" cy="347472"/>
           </a:xfrm>
           <a:prstGeom prst="rect">
@@ -6675,7 +6440,7 @@
         </p:nvSpPr>
         <p:spPr>
           <a:xfrm>
-            <a:off x="3246120" y="1188720"/>
+            <a:off x="3246120" y="1371600"/>
             <a:ext cx="2606040" cy="868680"/>
           </a:xfrm>
           <a:prstGeom prst="rect">
@@ -6733,7 +6498,7 @@
         </p:blipFill>
         <p:spPr>
           <a:xfrm>
-            <a:off x="2743200" y="2377440"/>
+            <a:off x="2743200" y="2514600"/>
             <a:ext cx="347472" cy="347472"/>
           </a:xfrm>
           <a:prstGeom prst="rect">
@@ -6749,7 +6514,7 @@
         </p:nvSpPr>
         <p:spPr>
           <a:xfrm>
-            <a:off x="3246120" y="2304288"/>
+            <a:off x="3246120" y="2441448"/>
             <a:ext cx="2606040" cy="868680"/>
           </a:xfrm>
           <a:prstGeom prst="rect">
@@ -6807,7 +6572,7 @@
         </p:blipFill>
         <p:spPr>
           <a:xfrm>
-            <a:off x="2743200" y="3493008"/>
+            <a:off x="2743200" y="3584448"/>
             <a:ext cx="347472" cy="347472"/>
           </a:xfrm>
           <a:prstGeom prst="rect">
@@ -6823,7 +6588,7 @@
         </p:nvSpPr>
         <p:spPr>
           <a:xfrm>
-            <a:off x="3246120" y="3419856"/>
+            <a:off x="3246120" y="3511296"/>
             <a:ext cx="2606040" cy="868680"/>
           </a:xfrm>
           <a:prstGeom prst="rect">
@@ -6862,51 +6627,6 @@
               <a:t>All Stow and ICQA associates</a:t>
             </a:r>
             <a:endParaRPr lang="en-US" sz="1700" dirty="0"/>
-          </a:p>
-        </p:txBody>
-      </p:sp>
-      <p:sp>
-        <p:nvSpPr>
-          <p:cNvPr id="25" name="Slide Number Placeholder 0"/>
-          <p:cNvSpPr>
-            <a:spLocks noGrp="1"/>
-          </p:cNvSpPr>
-          <p:nvPr>
-            <p:ph type="sldNum" sz="quarter" idx="4294967295"/>
-          </p:nvPr>
-        </p:nvSpPr>
-        <p:spPr>
-          <a:xfrm>
-            <a:off x="8503920" y="4754880"/>
-            <a:ext cx="365760" cy="274320"/>
-          </a:xfrm>
-          <a:prstGeom prst="rect">
-            <a:avLst/>
-          </a:prstGeom>
-          <a:extLst>
-            <a:ext uri="{C572A759-6A51-4108-AA02-DFA0A04FC94B}">
-              <ma14:wrappingTextBoxFlag xmlns:ma14="http://schemas.microsoft.com/office/mac/drawingml/2011/main" val="0"/>
-            </a:ext>
-          </a:extLst>
-        </p:spPr>
-        <p:txBody>
-          <a:bodyPr/>
-          <a:lstStyle>
-            <a:lvl1pPr>
-              <a:defRPr sz="1000">
-                <a:solidFill>
-                  <a:srgbClr val="8A97A5"/>
-                </a:solidFill>
-              </a:defRPr>
-            </a:lvl1pPr>
-          </a:lstStyle>
-          <a:p>
-            <a:pPr algn="l"/>
-            <a:fld id="{F7021451-1387-4CA6-816F-3879F97B5CBC}" type="slidenum">
-              <a:rPr b="0" lang="en-US"/>
-              <a:t>5</a:t>
-            </a:fld>
-            <a:endParaRPr lang="en-US"/>
           </a:p>
         </p:txBody>
       </p:sp>
@@ -6940,13 +6660,13 @@
           <p:cNvPr id="2" name="Text 0"/>
           <p:cNvSpPr/>
           <p:nvPr>
-            <p:ph idx="100" type="title" hasCustomPrompt="1"/>
+            <p:ph idx="101" type="title" hasCustomPrompt="1"/>
           </p:nvPr>
         </p:nvSpPr>
         <p:spPr>
           <a:xfrm>
-            <a:off x="457200" y="320040"/>
-            <a:ext cx="5394960" cy="685800"/>
+            <a:off x="457200" y="640080"/>
+            <a:ext cx="5394960" cy="548640"/>
           </a:xfrm>
           <a:prstGeom prst="rect">
             <a:avLst/>
@@ -6962,14 +6682,14 @@
               <a:buNone/>
             </a:pPr>
             <a:r>
-              <a:rPr lang="en-US" sz="3000" b="1" dirty="0">
+              <a:rPr lang="en-US" sz="2800" b="1" dirty="0">
                 <a:solidFill>
                   <a:schemeClr val="tx1"/>
                 </a:solidFill>
               </a:rPr>
               <a:t>How to do FFF in 4 steps</a:t>
             </a:r>
-            <a:endParaRPr lang="en-US" sz="3000" dirty="0"/>
+            <a:endParaRPr lang="en-US" sz="2800" dirty="0"/>
           </a:p>
         </p:txBody>
       </p:sp>
@@ -6981,8 +6701,8 @@
         </p:nvSpPr>
         <p:spPr>
           <a:xfrm>
-            <a:off x="457200" y="1143000"/>
-            <a:ext cx="566928" cy="566928"/>
+            <a:off x="457200" y="1325880"/>
+            <a:ext cx="548640" cy="548640"/>
           </a:xfrm>
           <a:prstGeom prst="ellipse">
             <a:avLst/>
@@ -7001,8 +6721,8 @@
         </p:nvSpPr>
         <p:spPr>
           <a:xfrm>
-            <a:off x="457200" y="1143000"/>
-            <a:ext cx="566928" cy="566928"/>
+            <a:off x="457200" y="1325880"/>
+            <a:ext cx="548640" cy="548640"/>
           </a:xfrm>
           <a:prstGeom prst="rect">
             <a:avLst/>
@@ -7037,7 +6757,7 @@
         </p:nvSpPr>
         <p:spPr>
           <a:xfrm>
-            <a:off x="1280160" y="1088136"/>
+            <a:off x="1280160" y="1261872"/>
             <a:ext cx="4572000" cy="685800"/>
           </a:xfrm>
           <a:prstGeom prst="rect">
@@ -7087,8 +6807,8 @@
         </p:nvSpPr>
         <p:spPr>
           <a:xfrm>
-            <a:off x="457200" y="1984248"/>
-            <a:ext cx="566928" cy="566928"/>
+            <a:off x="457200" y="2148840"/>
+            <a:ext cx="548640" cy="548640"/>
           </a:xfrm>
           <a:prstGeom prst="ellipse">
             <a:avLst/>
@@ -7107,8 +6827,8 @@
         </p:nvSpPr>
         <p:spPr>
           <a:xfrm>
-            <a:off x="457200" y="1984248"/>
-            <a:ext cx="566928" cy="566928"/>
+            <a:off x="457200" y="2148840"/>
+            <a:ext cx="548640" cy="548640"/>
           </a:xfrm>
           <a:prstGeom prst="rect">
             <a:avLst/>
@@ -7143,7 +6863,7 @@
         </p:nvSpPr>
         <p:spPr>
           <a:xfrm>
-            <a:off x="1280160" y="1929384"/>
+            <a:off x="1280160" y="2084832"/>
             <a:ext cx="4572000" cy="685800"/>
           </a:xfrm>
           <a:prstGeom prst="rect">
@@ -7193,8 +6913,8 @@
         </p:nvSpPr>
         <p:spPr>
           <a:xfrm>
-            <a:off x="457200" y="2825496"/>
-            <a:ext cx="566928" cy="566928"/>
+            <a:off x="457200" y="2971800"/>
+            <a:ext cx="548640" cy="548640"/>
           </a:xfrm>
           <a:prstGeom prst="ellipse">
             <a:avLst/>
@@ -7213,8 +6933,8 @@
         </p:nvSpPr>
         <p:spPr>
           <a:xfrm>
-            <a:off x="457200" y="2825496"/>
-            <a:ext cx="566928" cy="566928"/>
+            <a:off x="457200" y="2971800"/>
+            <a:ext cx="548640" cy="548640"/>
           </a:xfrm>
           <a:prstGeom prst="rect">
             <a:avLst/>
@@ -7249,7 +6969,7 @@
         </p:nvSpPr>
         <p:spPr>
           <a:xfrm>
-            <a:off x="1280160" y="2770632"/>
+            <a:off x="1280160" y="2907792"/>
             <a:ext cx="4572000" cy="685800"/>
           </a:xfrm>
           <a:prstGeom prst="rect">
@@ -7299,8 +7019,8 @@
         </p:nvSpPr>
         <p:spPr>
           <a:xfrm>
-            <a:off x="457200" y="3666744"/>
-            <a:ext cx="566928" cy="566928"/>
+            <a:off x="457200" y="3794760"/>
+            <a:ext cx="548640" cy="548640"/>
           </a:xfrm>
           <a:prstGeom prst="ellipse">
             <a:avLst/>
@@ -7319,8 +7039,8 @@
         </p:nvSpPr>
         <p:spPr>
           <a:xfrm>
-            <a:off x="457200" y="3666744"/>
-            <a:ext cx="566928" cy="566928"/>
+            <a:off x="457200" y="3794760"/>
+            <a:ext cx="548640" cy="548640"/>
           </a:xfrm>
           <a:prstGeom prst="rect">
             <a:avLst/>
@@ -7355,7 +7075,7 @@
         </p:nvSpPr>
         <p:spPr>
           <a:xfrm>
-            <a:off x="1280160" y="3611880"/>
+            <a:off x="1280160" y="3730752"/>
             <a:ext cx="4572000" cy="685800"/>
           </a:xfrm>
           <a:prstGeom prst="rect">
@@ -7394,51 +7114,6 @@
               <a:t>After 1 minute, or once the face meets ROBOTSS</a:t>
             </a:r>
             <a:endParaRPr lang="en-US" sz="1700" dirty="0"/>
-          </a:p>
-        </p:txBody>
-      </p:sp>
-      <p:sp>
-        <p:nvSpPr>
-          <p:cNvPr id="25" name="Slide Number Placeholder 0"/>
-          <p:cNvSpPr>
-            <a:spLocks noGrp="1"/>
-          </p:cNvSpPr>
-          <p:nvPr>
-            <p:ph type="sldNum" sz="quarter" idx="4294967295"/>
-          </p:nvPr>
-        </p:nvSpPr>
-        <p:spPr>
-          <a:xfrm>
-            <a:off x="8503920" y="4754880"/>
-            <a:ext cx="365760" cy="274320"/>
-          </a:xfrm>
-          <a:prstGeom prst="rect">
-            <a:avLst/>
-          </a:prstGeom>
-          <a:extLst>
-            <a:ext uri="{C572A759-6A51-4108-AA02-DFA0A04FC94B}">
-              <ma14:wrappingTextBoxFlag xmlns:ma14="http://schemas.microsoft.com/office/mac/drawingml/2011/main" val="0"/>
-            </a:ext>
-          </a:extLst>
-        </p:spPr>
-        <p:txBody>
-          <a:bodyPr/>
-          <a:lstStyle>
-            <a:lvl1pPr>
-              <a:defRPr sz="1000">
-                <a:solidFill>
-                  <a:srgbClr val="8A97A5"/>
-                </a:solidFill>
-              </a:defRPr>
-            </a:lvl1pPr>
-          </a:lstStyle>
-          <a:p>
-            <a:pPr algn="l"/>
-            <a:fld id="{F7021451-1387-4CA6-816F-3879F97B5CBC}" type="slidenum">
-              <a:rPr b="0" lang="en-US"/>
-              <a:t>6</a:t>
-            </a:fld>
-            <a:endParaRPr lang="en-US"/>
           </a:p>
         </p:txBody>
       </p:sp>
@@ -7472,13 +7147,13 @@
           <p:cNvPr id="2" name="Text 0"/>
           <p:cNvSpPr/>
           <p:nvPr>
-            <p:ph idx="100" type="title" hasCustomPrompt="1"/>
+            <p:ph idx="101" type="title" hasCustomPrompt="1"/>
           </p:nvPr>
         </p:nvSpPr>
         <p:spPr>
           <a:xfrm>
-            <a:off x="457200" y="320040"/>
-            <a:ext cx="5394960" cy="685800"/>
+            <a:off x="457200" y="640080"/>
+            <a:ext cx="5394960" cy="548640"/>
           </a:xfrm>
           <a:prstGeom prst="rect">
             <a:avLst/>
@@ -7494,14 +7169,14 @@
               <a:buNone/>
             </a:pPr>
             <a:r>
-              <a:rPr lang="en-US" sz="3000" b="1" dirty="0">
+              <a:rPr lang="en-US" sz="2800" b="1" dirty="0">
                 <a:solidFill>
                   <a:schemeClr val="tx1"/>
                 </a:solidFill>
               </a:rPr>
               <a:t>During FFF, do NOT</a:t>
             </a:r>
-            <a:endParaRPr lang="en-US" sz="3000" dirty="0"/>
+            <a:endParaRPr lang="en-US" sz="2800" dirty="0"/>
           </a:p>
         </p:txBody>
       </p:sp>
@@ -7513,8 +7188,8 @@
         </p:nvSpPr>
         <p:spPr>
           <a:xfrm>
-            <a:off x="457200" y="1143000"/>
-            <a:ext cx="1691640" cy="2240280"/>
+            <a:off x="457200" y="1325880"/>
+            <a:ext cx="1691640" cy="2194560"/>
           </a:xfrm>
           <a:prstGeom prst="roundRect">
             <a:avLst>
@@ -7543,7 +7218,7 @@
         </p:blipFill>
         <p:spPr>
           <a:xfrm>
-            <a:off x="685800" y="1371600"/>
+            <a:off x="685800" y="1554480"/>
             <a:ext cx="457200" cy="457200"/>
           </a:xfrm>
           <a:prstGeom prst="rect">
@@ -7567,7 +7242,7 @@
         </p:blipFill>
         <p:spPr>
           <a:xfrm>
-            <a:off x="1554480" y="1371600"/>
+            <a:off x="1554480" y="1554480"/>
             <a:ext cx="365760" cy="365760"/>
           </a:xfrm>
           <a:prstGeom prst="rect">
@@ -7583,7 +7258,7 @@
         </p:nvSpPr>
         <p:spPr>
           <a:xfrm>
-            <a:off x="685800" y="2011680"/>
+            <a:off x="685800" y="2194560"/>
             <a:ext cx="1280160" cy="1234440"/>
           </a:xfrm>
           <a:prstGeom prst="rect">
@@ -7633,8 +7308,8 @@
         </p:nvSpPr>
         <p:spPr>
           <a:xfrm>
-            <a:off x="2286000" y="1143000"/>
-            <a:ext cx="1691640" cy="2240280"/>
+            <a:off x="2286000" y="1325880"/>
+            <a:ext cx="1691640" cy="2194560"/>
           </a:xfrm>
           <a:prstGeom prst="roundRect">
             <a:avLst>
@@ -7663,7 +7338,7 @@
         </p:blipFill>
         <p:spPr>
           <a:xfrm>
-            <a:off x="2514600" y="1371600"/>
+            <a:off x="2514600" y="1554480"/>
             <a:ext cx="457200" cy="457200"/>
           </a:xfrm>
           <a:prstGeom prst="rect">
@@ -7687,7 +7362,7 @@
         </p:blipFill>
         <p:spPr>
           <a:xfrm>
-            <a:off x="3383280" y="1371600"/>
+            <a:off x="3383280" y="1554480"/>
             <a:ext cx="365760" cy="365760"/>
           </a:xfrm>
           <a:prstGeom prst="rect">
@@ -7703,7 +7378,7 @@
         </p:nvSpPr>
         <p:spPr>
           <a:xfrm>
-            <a:off x="2514600" y="2011680"/>
+            <a:off x="2514600" y="2194560"/>
             <a:ext cx="1280160" cy="1234440"/>
           </a:xfrm>
           <a:prstGeom prst="rect">
@@ -7753,8 +7428,8 @@
         </p:nvSpPr>
         <p:spPr>
           <a:xfrm>
-            <a:off x="4114800" y="1143000"/>
-            <a:ext cx="1691640" cy="2240280"/>
+            <a:off x="4114800" y="1325880"/>
+            <a:ext cx="1691640" cy="2194560"/>
           </a:xfrm>
           <a:prstGeom prst="roundRect">
             <a:avLst>
@@ -7783,7 +7458,7 @@
         </p:blipFill>
         <p:spPr>
           <a:xfrm>
-            <a:off x="4343400" y="1371600"/>
+            <a:off x="4343400" y="1554480"/>
             <a:ext cx="457200" cy="457200"/>
           </a:xfrm>
           <a:prstGeom prst="rect">
@@ -7807,7 +7482,7 @@
         </p:blipFill>
         <p:spPr>
           <a:xfrm>
-            <a:off x="5212080" y="1371600"/>
+            <a:off x="5212080" y="1554480"/>
             <a:ext cx="365760" cy="365760"/>
           </a:xfrm>
           <a:prstGeom prst="rect">
@@ -7823,7 +7498,7 @@
         </p:nvSpPr>
         <p:spPr>
           <a:xfrm>
-            <a:off x="4343400" y="2011680"/>
+            <a:off x="4343400" y="2194560"/>
             <a:ext cx="1280160" cy="1234440"/>
           </a:xfrm>
           <a:prstGeom prst="rect">
@@ -7881,7 +7556,7 @@
         </p:blipFill>
         <p:spPr>
           <a:xfrm>
-            <a:off x="457200" y="3721608"/>
+            <a:off x="457200" y="3886200"/>
             <a:ext cx="365760" cy="365760"/>
           </a:xfrm>
           <a:prstGeom prst="rect">
@@ -7897,7 +7572,7 @@
         </p:nvSpPr>
         <p:spPr>
           <a:xfrm>
-            <a:off x="1005840" y="3611880"/>
+            <a:off x="1005840" y="3776472"/>
             <a:ext cx="4846320" cy="594360"/>
           </a:xfrm>
           <a:prstGeom prst="rect">
@@ -7922,51 +7597,6 @@
               <a:t>FFF is only about organizing what is already in each bin.</a:t>
             </a:r>
             <a:endParaRPr lang="en-US" sz="1600" dirty="0"/>
-          </a:p>
-        </p:txBody>
-      </p:sp>
-      <p:sp>
-        <p:nvSpPr>
-          <p:cNvPr id="25" name="Slide Number Placeholder 0"/>
-          <p:cNvSpPr>
-            <a:spLocks noGrp="1"/>
-          </p:cNvSpPr>
-          <p:nvPr>
-            <p:ph type="sldNum" sz="quarter" idx="4294967295"/>
-          </p:nvPr>
-        </p:nvSpPr>
-        <p:spPr>
-          <a:xfrm>
-            <a:off x="8503920" y="4754880"/>
-            <a:ext cx="365760" cy="274320"/>
-          </a:xfrm>
-          <a:prstGeom prst="rect">
-            <a:avLst/>
-          </a:prstGeom>
-          <a:extLst>
-            <a:ext uri="{C572A759-6A51-4108-AA02-DFA0A04FC94B}">
-              <ma14:wrappingTextBoxFlag xmlns:ma14="http://schemas.microsoft.com/office/mac/drawingml/2011/main" val="0"/>
-            </a:ext>
-          </a:extLst>
-        </p:spPr>
-        <p:txBody>
-          <a:bodyPr/>
-          <a:lstStyle>
-            <a:lvl1pPr>
-              <a:defRPr sz="1000">
-                <a:solidFill>
-                  <a:srgbClr val="8A97A5"/>
-                </a:solidFill>
-              </a:defRPr>
-            </a:lvl1pPr>
-          </a:lstStyle>
-          <a:p>
-            <a:pPr algn="l"/>
-            <a:fld id="{F7021451-1387-4CA6-816F-3879F97B5CBC}" type="slidenum">
-              <a:rPr b="0" lang="en-US"/>
-              <a:t>7</a:t>
-            </a:fld>
-            <a:endParaRPr lang="en-US"/>
           </a:p>
         </p:txBody>
       </p:sp>
@@ -8000,13 +7630,13 @@
           <p:cNvPr id="2" name="Text 0"/>
           <p:cNvSpPr/>
           <p:nvPr>
-            <p:ph idx="100" type="title" hasCustomPrompt="1"/>
+            <p:ph idx="101" type="title" hasCustomPrompt="1"/>
           </p:nvPr>
         </p:nvSpPr>
         <p:spPr>
           <a:xfrm>
-            <a:off x="457200" y="320040"/>
-            <a:ext cx="5394960" cy="685800"/>
+            <a:off x="457200" y="640080"/>
+            <a:ext cx="5394960" cy="548640"/>
           </a:xfrm>
           <a:prstGeom prst="rect">
             <a:avLst/>
@@ -8022,14 +7652,14 @@
               <a:buNone/>
             </a:pPr>
             <a:r>
-              <a:rPr lang="en-US" sz="3000" b="1" dirty="0">
+              <a:rPr lang="en-US" sz="2800" b="1" dirty="0">
                 <a:solidFill>
                   <a:schemeClr val="tx1"/>
                 </a:solidFill>
               </a:rPr>
               <a:t>Then keep fixing as you go</a:t>
             </a:r>
-            <a:endParaRPr lang="en-US" sz="3000" dirty="0"/>
+            <a:endParaRPr lang="en-US" sz="2800" dirty="0"/>
           </a:p>
         </p:txBody>
       </p:sp>
@@ -8041,16 +7671,16 @@
         </p:nvSpPr>
         <p:spPr>
           <a:xfrm>
-            <a:off x="457200" y="1143000"/>
-            <a:ext cx="5394960" cy="1234440"/>
+            <a:off x="457200" y="1325880"/>
+            <a:ext cx="5394960" cy="1188720"/>
           </a:xfrm>
           <a:prstGeom prst="roundRect">
             <a:avLst>
-              <a:gd name="adj" fmla="val 7407"/>
+              <a:gd name="adj" fmla="val 7692"/>
             </a:avLst>
           </a:prstGeom>
           <a:solidFill>
-            <a:schemeClr val="bg2"/>
+            <a:schemeClr val="bg1"/>
           </a:solidFill>
           <a:ln/>
         </p:spPr>
@@ -8071,7 +7701,7 @@
         </p:blipFill>
         <p:spPr>
           <a:xfrm>
-            <a:off x="731520" y="1554480"/>
+            <a:off x="731520" y="1709928"/>
             <a:ext cx="411480" cy="411480"/>
           </a:xfrm>
           <a:prstGeom prst="rect">
@@ -8087,8 +7717,8 @@
         </p:nvSpPr>
         <p:spPr>
           <a:xfrm>
-            <a:off x="1371600" y="1143000"/>
-            <a:ext cx="4297680" cy="1234440"/>
+            <a:off x="1371600" y="1325880"/>
+            <a:ext cx="4297680" cy="1188720"/>
           </a:xfrm>
           <a:prstGeom prst="rect">
             <a:avLst/>
@@ -8137,8 +7767,8 @@
         </p:nvSpPr>
         <p:spPr>
           <a:xfrm>
-            <a:off x="457200" y="2651760"/>
-            <a:ext cx="2606040" cy="1554480"/>
+            <a:off x="457200" y="2743200"/>
+            <a:ext cx="2606040" cy="1463040"/>
           </a:xfrm>
           <a:prstGeom prst="rect">
             <a:avLst/>
@@ -8187,8 +7817,8 @@
         </p:nvSpPr>
         <p:spPr>
           <a:xfrm>
-            <a:off x="3246120" y="2651760"/>
-            <a:ext cx="2606040" cy="1554480"/>
+            <a:off x="3246120" y="2743200"/>
+            <a:ext cx="2606040" cy="1463040"/>
           </a:xfrm>
           <a:prstGeom prst="rect">
             <a:avLst/>
@@ -8237,8 +7867,8 @@
         </p:nvSpPr>
         <p:spPr>
           <a:xfrm>
-            <a:off x="457200" y="4251960"/>
-            <a:ext cx="5394960" cy="365760"/>
+            <a:off x="457200" y="4343400"/>
+            <a:ext cx="5394960" cy="320040"/>
           </a:xfrm>
           <a:prstGeom prst="rect">
             <a:avLst/>
@@ -8256,57 +7886,12 @@
             <a:r>
               <a:rPr lang="en-US" sz="1200" dirty="0">
                 <a:solidFill>
-                  <a:srgbClr val="8A97A5"/>
+                  <a:srgbClr val="7A8795"/>
                 </a:solidFill>
               </a:rPr>
               <a:t>Audited by ICQA, Ops and L&amp;D, with feedback on the spot</a:t>
             </a:r>
             <a:endParaRPr lang="en-US" sz="1200" dirty="0"/>
-          </a:p>
-        </p:txBody>
-      </p:sp>
-      <p:sp>
-        <p:nvSpPr>
-          <p:cNvPr id="25" name="Slide Number Placeholder 0"/>
-          <p:cNvSpPr>
-            <a:spLocks noGrp="1"/>
-          </p:cNvSpPr>
-          <p:nvPr>
-            <p:ph type="sldNum" sz="quarter" idx="4294967295"/>
-          </p:nvPr>
-        </p:nvSpPr>
-        <p:spPr>
-          <a:xfrm>
-            <a:off x="8503920" y="4754880"/>
-            <a:ext cx="365760" cy="274320"/>
-          </a:xfrm>
-          <a:prstGeom prst="rect">
-            <a:avLst/>
-          </a:prstGeom>
-          <a:extLst>
-            <a:ext uri="{C572A759-6A51-4108-AA02-DFA0A04FC94B}">
-              <ma14:wrappingTextBoxFlag xmlns:ma14="http://schemas.microsoft.com/office/mac/drawingml/2011/main" val="0"/>
-            </a:ext>
-          </a:extLst>
-        </p:spPr>
-        <p:txBody>
-          <a:bodyPr/>
-          <a:lstStyle>
-            <a:lvl1pPr>
-              <a:defRPr sz="1000">
-                <a:solidFill>
-                  <a:srgbClr val="8A97A5"/>
-                </a:solidFill>
-              </a:defRPr>
-            </a:lvl1pPr>
-          </a:lstStyle>
-          <a:p>
-            <a:pPr algn="l"/>
-            <a:fld id="{F7021451-1387-4CA6-816F-3879F97B5CBC}" type="slidenum">
-              <a:rPr b="0" lang="en-US"/>
-              <a:t>8</a:t>
-            </a:fld>
-            <a:endParaRPr lang="en-US"/>
           </a:p>
         </p:txBody>
       </p:sp>
@@ -8337,83 +7922,7 @@
       </p:grpSpPr>
       <p:sp>
         <p:nvSpPr>
-          <p:cNvPr id="2" name="Text 0"/>
-          <p:cNvSpPr/>
-          <p:nvPr>
-            <p:ph idx="100" type="body" hasCustomPrompt="1"/>
-          </p:nvPr>
-        </p:nvSpPr>
-        <p:spPr>
-          <a:xfrm>
-            <a:off x="457200" y="1143000"/>
-            <a:ext cx="5394960" cy="365760"/>
-          </a:xfrm>
-          <a:prstGeom prst="rect">
-            <a:avLst/>
-          </a:prstGeom>
-          <a:noFill/>
-          <a:ln/>
-        </p:spPr>
-        <p:txBody>
-          <a:bodyPr wrap="square" lIns="0" tIns="0" rIns="0" bIns="0" rtlCol="0"/>
-          <a:lstStyle/>
-          <a:p>
-            <a:pPr indent="0" marL="0">
-              <a:buNone/>
-            </a:pPr>
-            <a:r>
-              <a:rPr lang="en-US" sz="1400" b="1" spc="300" kern="0" dirty="0">
-                <a:solidFill>
-                  <a:schemeClr val="accent1"/>
-                </a:solidFill>
-              </a:rPr>
-              <a:t>PART 2</a:t>
-            </a:r>
-            <a:endParaRPr lang="en-US" sz="1400" dirty="0"/>
-          </a:p>
-        </p:txBody>
-      </p:sp>
-      <p:sp>
-        <p:nvSpPr>
-          <p:cNvPr id="3" name="Text 0"/>
-          <p:cNvSpPr/>
-          <p:nvPr>
-            <p:ph idx="101" type="title" hasCustomPrompt="1"/>
-          </p:nvPr>
-        </p:nvSpPr>
-        <p:spPr>
-          <a:xfrm>
-            <a:off x="457200" y="1554480"/>
-            <a:ext cx="5394960" cy="1463040"/>
-          </a:xfrm>
-          <a:prstGeom prst="rect">
-            <a:avLst/>
-          </a:prstGeom>
-          <a:noFill/>
-          <a:ln/>
-        </p:spPr>
-        <p:txBody>
-          <a:bodyPr wrap="square" lIns="0" tIns="0" rIns="0" bIns="0" rtlCol="0" anchor="t"/>
-          <a:lstStyle/>
-          <a:p>
-            <a:pPr algn="l" indent="0" marL="0">
-              <a:buNone/>
-            </a:pPr>
-            <a:r>
-              <a:rPr lang="en-US" sz="4000" b="1" dirty="0">
-                <a:solidFill>
-                  <a:schemeClr val="bg1"/>
-                </a:solidFill>
-              </a:rPr>
-              <a:t>Bin Etiquette: ROBOTSS</a:t>
-            </a:r>
-            <a:endParaRPr lang="en-US" sz="4000" dirty="0"/>
-          </a:p>
-        </p:txBody>
-      </p:sp>
-      <p:sp>
-        <p:nvSpPr>
-          <p:cNvPr id="4" name="Text 0"/>
+          <p:cNvPr id="2" name="Text 1"/>
           <p:cNvSpPr/>
           <p:nvPr>
             <p:ph idx="102" type="body" hasCustomPrompt="1"/>
@@ -8421,8 +7930,84 @@
         </p:nvSpPr>
         <p:spPr>
           <a:xfrm>
-            <a:off x="457200" y="3063240"/>
-            <a:ext cx="4846320" cy="822960"/>
+            <a:off x="2514600" y="502920"/>
+            <a:ext cx="6400800" cy="320040"/>
+          </a:xfrm>
+          <a:prstGeom prst="rect">
+            <a:avLst/>
+          </a:prstGeom>
+          <a:noFill/>
+          <a:ln/>
+        </p:spPr>
+        <p:txBody>
+          <a:bodyPr wrap="square" lIns="0" tIns="0" rIns="0" bIns="0" rtlCol="0"/>
+          <a:lstStyle/>
+          <a:p>
+            <a:pPr algn="ctr" indent="0" marL="0">
+              <a:buNone/>
+            </a:pPr>
+            <a:r>
+              <a:rPr lang="en-US" sz="1300" b="1" spc="300" kern="0" dirty="0">
+                <a:solidFill>
+                  <a:schemeClr val="accent6"/>
+                </a:solidFill>
+              </a:rPr>
+              <a:t>PART 2</a:t>
+            </a:r>
+            <a:endParaRPr lang="en-US" sz="1300" dirty="0"/>
+          </a:p>
+        </p:txBody>
+      </p:sp>
+      <p:sp>
+        <p:nvSpPr>
+          <p:cNvPr id="3" name="Text 1"/>
+          <p:cNvSpPr/>
+          <p:nvPr>
+            <p:ph idx="103" type="title" hasCustomPrompt="1"/>
+          </p:nvPr>
+        </p:nvSpPr>
+        <p:spPr>
+          <a:xfrm>
+            <a:off x="2514600" y="868680"/>
+            <a:ext cx="6400800" cy="868680"/>
+          </a:xfrm>
+          <a:prstGeom prst="rect">
+            <a:avLst/>
+          </a:prstGeom>
+          <a:noFill/>
+          <a:ln/>
+        </p:spPr>
+        <p:txBody>
+          <a:bodyPr wrap="square" lIns="0" tIns="0" rIns="0" bIns="0" rtlCol="0" anchor="ctr"/>
+          <a:lstStyle/>
+          <a:p>
+            <a:pPr algn="ctr" indent="0" marL="0">
+              <a:buNone/>
+            </a:pPr>
+            <a:r>
+              <a:rPr lang="en-US" sz="3600" b="1" dirty="0">
+                <a:solidFill>
+                  <a:schemeClr val="tx1"/>
+                </a:solidFill>
+              </a:rPr>
+              <a:t>Bin Etiquette: ROBOTSS</a:t>
+            </a:r>
+            <a:endParaRPr lang="en-US" sz="3600" dirty="0"/>
+          </a:p>
+        </p:txBody>
+      </p:sp>
+      <p:sp>
+        <p:nvSpPr>
+          <p:cNvPr id="4" name="Text 1"/>
+          <p:cNvSpPr/>
+          <p:nvPr>
+            <p:ph idx="104" type="body" hasCustomPrompt="1"/>
+          </p:nvPr>
+        </p:nvSpPr>
+        <p:spPr>
+          <a:xfrm>
+            <a:off x="2971800" y="1783080"/>
+            <a:ext cx="5486400" cy="685800"/>
           </a:xfrm>
           <a:prstGeom prst="rect">
             <a:avLst/>
@@ -8434,45 +8019,21 @@
           <a:bodyPr wrap="square" lIns="0" tIns="0" rIns="0" bIns="0" rtlCol="0" anchor="t"/>
           <a:lstStyle/>
           <a:p>
-            <a:pPr indent="0" marL="0">
-              <a:buNone/>
-            </a:pPr>
-            <a:r>
-              <a:rPr lang="en-US" sz="1800" dirty="0">
-                <a:solidFill>
-                  <a:srgbClr val="C9D3DD"/>
+            <a:pPr algn="ctr" indent="0" marL="0">
+              <a:buNone/>
+            </a:pPr>
+            <a:r>
+              <a:rPr lang="en-US" sz="1600" dirty="0">
+                <a:solidFill>
+                  <a:schemeClr val="accent4"/>
                 </a:solidFill>
               </a:rPr>
               <a:t>Seven rules for every bin you touch, in Stow, Pick and ICQA.</a:t>
             </a:r>
-            <a:endParaRPr lang="en-US" sz="1800" dirty="0"/>
-          </a:p>
-        </p:txBody>
-      </p:sp>
-      <p:pic>
-        <p:nvPicPr>
-          <p:cNvPr id="5" name="Section icon" descr="preencoded.png">    </p:cNvPr>
-          <p:cNvPicPr>
-            <a:picLocks noChangeAspect="1"/>
-          </p:cNvPicPr>
-          <p:nvPr/>
-        </p:nvPicPr>
-        <p:blipFill>
-          <a:blip r:embed="rId1"/>
-          <a:stretch>
-            <a:fillRect/>
-          </a:stretch>
-        </p:blipFill>
-        <p:spPr>
-          <a:xfrm>
-            <a:off x="457200" y="457200"/>
-            <a:ext cx="502920" cy="502920"/>
-          </a:xfrm>
-          <a:prstGeom prst="rect">
-            <a:avLst/>
-          </a:prstGeom>
-        </p:spPr>
-      </p:pic>
+            <a:endParaRPr lang="en-US" sz="1600" dirty="0"/>
+          </a:p>
+        </p:txBody>
+      </p:sp>
     </p:spTree>
   </p:cSld>
   <p:clrMapOvr>
@@ -8482,23 +8043,23 @@
 </file>
 
 <file path=ppt/theme/theme1.xml><?xml version="1.0" encoding="utf-8"?>
-<a:theme xmlns:a="http://schemas.openxmlformats.org/drawingml/2006/main" name="Amnesty Coaching">
+<a:theme xmlns:a="http://schemas.openxmlformats.org/drawingml/2006/main" name="L&amp;D Field Team">
   <a:themeElements>
-    <a:clrScheme name="Amnesty Coaching">
+    <a:clrScheme name="L&amp;D Field Team">
       <a:dk1>
-        <a:srgbClr val="1B2430"/>
+        <a:srgbClr val="121921"/>
       </a:dk1>
       <a:lt1>
         <a:srgbClr val="FFFFFF"/>
       </a:lt1>
       <a:dk2>
-        <a:srgbClr val="14202C"/>
+        <a:srgbClr val="37475A"/>
       </a:dk2>
       <a:lt2>
-        <a:srgbClr val="EEF2F5"/>
+        <a:srgbClr val="F5F6FA"/>
       </a:lt2>
       <a:accent1>
-        <a:srgbClr val="FF7A1A"/>
+        <a:srgbClr val="02A6E1"/>
       </a:accent1>
       <a:accent2>
         <a:srgbClr val="1E8C7E"/>
@@ -8510,19 +8071,19 @@
         <a:srgbClr val="5B6B7B"/>
       </a:accent4>
       <a:accent5>
-        <a:srgbClr val="FFC24D"/>
+        <a:srgbClr val="FFB400"/>
       </a:accent5>
       <a:accent6>
-        <a:srgbClr val="3A7BD5"/>
+        <a:srgbClr val="0B6E99"/>
       </a:accent6>
       <a:hlink>
-        <a:srgbClr val="3A7BD5"/>
+        <a:srgbClr val="0B6E99"/>
       </a:hlink>
       <a:folHlink>
         <a:srgbClr val="5B6B7B"/>
       </a:folHlink>
     </a:clrScheme>
-    <a:fontScheme name="Amnesty Coaching">
+    <a:fontScheme name="L&amp;D Field Team">
       <a:majorFont>
         <a:latin typeface="Arial"/>
         <a:ea typeface=""/>

</xml_diff>